<commit_message>
Agrupar material auxiliar en soporte
</commit_message>
<xml_diff>
--- a/1_presentacion/PRESENTACION_MODELOS_FINAL.pptx
+++ b/1_presentacion/PRESENTACION_MODELOS_FINAL.pptx
@@ -3772,7 +3772,7 @@
         <p:spPr>
           <a:xfrm>
             <a:off x="731520" y="1097280"/>
-            <a:ext cx="2194560" cy="960120"/>
+            <a:ext cx="2194560" cy="1078992"/>
           </a:xfrm>
           <a:prstGeom prst="roundRect">
             <a:avLst/>
@@ -3781,9 +3781,7 @@
             <a:srgbClr val="F8F8F8"/>
           </a:solidFill>
           <a:ln>
-            <a:solidFill>
-              <a:srgbClr val="D2D2D2"/>
-            </a:solidFill>
+            <a:noFill/>
           </a:ln>
         </p:spPr>
         <p:style>
@@ -3816,25 +3814,25 @@
         </p:nvSpPr>
         <p:spPr>
           <a:xfrm>
-            <a:off x="841248" y="1197864"/>
-            <a:ext cx="1975104" cy="201168"/>
-          </a:xfrm>
-          <a:prstGeom prst="rect">
-            <a:avLst/>
-          </a:prstGeom>
-          <a:noFill/>
-        </p:spPr>
-        <p:txBody>
-          <a:bodyPr wrap="square" anchor="t" lIns="18288" rIns="18288">
-            <a:normAutofit/>
-          </a:bodyPr>
-          <a:lstStyle/>
-          <a:p>
-            <a:pPr algn="l"/>
+            <a:off x="841248" y="1188720"/>
+            <a:ext cx="1975104" cy="219456"/>
+          </a:xfrm>
+          <a:prstGeom prst="rect">
+            <a:avLst/>
+          </a:prstGeom>
+          <a:noFill/>
+        </p:spPr>
+        <p:txBody>
+          <a:bodyPr wrap="square" anchor="t" lIns="45720" rIns="45720" tIns="18288" bIns="18288">
+            <a:normAutofit/>
+          </a:bodyPr>
+          <a:lstStyle/>
+          <a:p>
+            <a:pPr algn="ctr"/>
             <a:r>
               <a:rPr sz="1050" b="1">
                 <a:solidFill>
-                  <a:srgbClr val="000000"/>
+                  <a:srgbClr val="5F5F5F"/>
                 </a:solidFill>
                 <a:latin typeface="Aptos"/>
               </a:rPr>
@@ -3851,23 +3849,23 @@
         </p:nvSpPr>
         <p:spPr>
           <a:xfrm>
-            <a:off x="841248" y="1463040"/>
-            <a:ext cx="1975104" cy="411480"/>
-          </a:xfrm>
-          <a:prstGeom prst="rect">
-            <a:avLst/>
-          </a:prstGeom>
-          <a:noFill/>
-        </p:spPr>
-        <p:txBody>
-          <a:bodyPr wrap="square" anchor="t" lIns="18288" rIns="18288">
-            <a:normAutofit/>
-          </a:bodyPr>
-          <a:lstStyle/>
-          <a:p>
-            <a:pPr algn="l"/>
-            <a:r>
-              <a:rPr sz="2100" b="1">
+            <a:off x="841248" y="1453896"/>
+            <a:ext cx="1975104" cy="329184"/>
+          </a:xfrm>
+          <a:prstGeom prst="rect">
+            <a:avLst/>
+          </a:prstGeom>
+          <a:noFill/>
+        </p:spPr>
+        <p:txBody>
+          <a:bodyPr wrap="square" anchor="t" lIns="45720" rIns="45720" tIns="18288" bIns="18288">
+            <a:normAutofit/>
+          </a:bodyPr>
+          <a:lstStyle/>
+          <a:p>
+            <a:pPr algn="ctr"/>
+            <a:r>
+              <a:rPr sz="1800" b="1">
                 <a:solidFill>
                   <a:srgbClr val="000000"/>
                 </a:solidFill>
@@ -3886,25 +3884,25 @@
         </p:nvSpPr>
         <p:spPr>
           <a:xfrm>
-            <a:off x="841248" y="1892807"/>
-            <a:ext cx="1975104" cy="228600"/>
-          </a:xfrm>
-          <a:prstGeom prst="rect">
-            <a:avLst/>
-          </a:prstGeom>
-          <a:noFill/>
-        </p:spPr>
-        <p:txBody>
-          <a:bodyPr wrap="square" anchor="t" lIns="18288" rIns="18288">
-            <a:normAutofit/>
-          </a:bodyPr>
-          <a:lstStyle/>
-          <a:p>
-            <a:pPr algn="l"/>
-            <a:r>
-              <a:rPr sz="919" b="0">
-                <a:solidFill>
-                  <a:srgbClr val="000000"/>
+            <a:off x="841248" y="1847088"/>
+            <a:ext cx="1975104" cy="246888"/>
+          </a:xfrm>
+          <a:prstGeom prst="rect">
+            <a:avLst/>
+          </a:prstGeom>
+          <a:noFill/>
+        </p:spPr>
+        <p:txBody>
+          <a:bodyPr wrap="square" anchor="t" lIns="45720" rIns="45720" tIns="18288" bIns="18288">
+            <a:normAutofit/>
+          </a:bodyPr>
+          <a:lstStyle/>
+          <a:p>
+            <a:pPr algn="ctr"/>
+            <a:r>
+              <a:rPr sz="860" b="0">
+                <a:solidFill>
+                  <a:srgbClr val="5F5F5F"/>
                 </a:solidFill>
                 <a:latin typeface="Aptos"/>
               </a:rPr>
@@ -3922,7 +3920,7 @@
         <p:spPr>
           <a:xfrm>
             <a:off x="3337560" y="1097280"/>
-            <a:ext cx="2194560" cy="960120"/>
+            <a:ext cx="2194560" cy="1078992"/>
           </a:xfrm>
           <a:prstGeom prst="roundRect">
             <a:avLst/>
@@ -3931,9 +3929,7 @@
             <a:srgbClr val="F8F8F8"/>
           </a:solidFill>
           <a:ln>
-            <a:solidFill>
-              <a:srgbClr val="D2D2D2"/>
-            </a:solidFill>
+            <a:noFill/>
           </a:ln>
         </p:spPr>
         <p:style>
@@ -3966,25 +3962,25 @@
         </p:nvSpPr>
         <p:spPr>
           <a:xfrm>
-            <a:off x="3447288" y="1197864"/>
-            <a:ext cx="1975104" cy="201168"/>
-          </a:xfrm>
-          <a:prstGeom prst="rect">
-            <a:avLst/>
-          </a:prstGeom>
-          <a:noFill/>
-        </p:spPr>
-        <p:txBody>
-          <a:bodyPr wrap="square" anchor="t" lIns="18288" rIns="18288">
-            <a:normAutofit/>
-          </a:bodyPr>
-          <a:lstStyle/>
-          <a:p>
-            <a:pPr algn="l"/>
+            <a:off x="3447288" y="1188720"/>
+            <a:ext cx="1975104" cy="219456"/>
+          </a:xfrm>
+          <a:prstGeom prst="rect">
+            <a:avLst/>
+          </a:prstGeom>
+          <a:noFill/>
+        </p:spPr>
+        <p:txBody>
+          <a:bodyPr wrap="square" anchor="t" lIns="45720" rIns="45720" tIns="18288" bIns="18288">
+            <a:normAutofit/>
+          </a:bodyPr>
+          <a:lstStyle/>
+          <a:p>
+            <a:pPr algn="ctr"/>
             <a:r>
               <a:rPr sz="1050" b="1">
                 <a:solidFill>
-                  <a:srgbClr val="000000"/>
+                  <a:srgbClr val="5F5F5F"/>
                 </a:solidFill>
                 <a:latin typeface="Aptos"/>
               </a:rPr>
@@ -4001,23 +3997,23 @@
         </p:nvSpPr>
         <p:spPr>
           <a:xfrm>
-            <a:off x="3447288" y="1463040"/>
-            <a:ext cx="1975104" cy="411480"/>
-          </a:xfrm>
-          <a:prstGeom prst="rect">
-            <a:avLst/>
-          </a:prstGeom>
-          <a:noFill/>
-        </p:spPr>
-        <p:txBody>
-          <a:bodyPr wrap="square" anchor="t" lIns="18288" rIns="18288">
-            <a:normAutofit/>
-          </a:bodyPr>
-          <a:lstStyle/>
-          <a:p>
-            <a:pPr algn="l"/>
-            <a:r>
-              <a:rPr sz="2100" b="1">
+            <a:off x="3447288" y="1453896"/>
+            <a:ext cx="1975104" cy="329184"/>
+          </a:xfrm>
+          <a:prstGeom prst="rect">
+            <a:avLst/>
+          </a:prstGeom>
+          <a:noFill/>
+        </p:spPr>
+        <p:txBody>
+          <a:bodyPr wrap="square" anchor="t" lIns="45720" rIns="45720" tIns="18288" bIns="18288">
+            <a:normAutofit/>
+          </a:bodyPr>
+          <a:lstStyle/>
+          <a:p>
+            <a:pPr algn="ctr"/>
+            <a:r>
+              <a:rPr sz="1800" b="1">
                 <a:solidFill>
                   <a:srgbClr val="000000"/>
                 </a:solidFill>
@@ -4036,25 +4032,25 @@
         </p:nvSpPr>
         <p:spPr>
           <a:xfrm>
-            <a:off x="3447288" y="1892807"/>
-            <a:ext cx="1975104" cy="228600"/>
-          </a:xfrm>
-          <a:prstGeom prst="rect">
-            <a:avLst/>
-          </a:prstGeom>
-          <a:noFill/>
-        </p:spPr>
-        <p:txBody>
-          <a:bodyPr wrap="square" anchor="t" lIns="18288" rIns="18288">
-            <a:normAutofit/>
-          </a:bodyPr>
-          <a:lstStyle/>
-          <a:p>
-            <a:pPr algn="l"/>
-            <a:r>
-              <a:rPr sz="919" b="0">
-                <a:solidFill>
-                  <a:srgbClr val="000000"/>
+            <a:off x="3447288" y="1847088"/>
+            <a:ext cx="1975104" cy="246888"/>
+          </a:xfrm>
+          <a:prstGeom prst="rect">
+            <a:avLst/>
+          </a:prstGeom>
+          <a:noFill/>
+        </p:spPr>
+        <p:txBody>
+          <a:bodyPr wrap="square" anchor="t" lIns="45720" rIns="45720" tIns="18288" bIns="18288">
+            <a:normAutofit/>
+          </a:bodyPr>
+          <a:lstStyle/>
+          <a:p>
+            <a:pPr algn="ctr"/>
+            <a:r>
+              <a:rPr sz="860" b="0">
+                <a:solidFill>
+                  <a:srgbClr val="5F5F5F"/>
                 </a:solidFill>
                 <a:latin typeface="Aptos"/>
               </a:rPr>
@@ -4072,7 +4068,7 @@
         <p:spPr>
           <a:xfrm>
             <a:off x="5943600" y="1097280"/>
-            <a:ext cx="2194560" cy="960120"/>
+            <a:ext cx="2194560" cy="1078992"/>
           </a:xfrm>
           <a:prstGeom prst="roundRect">
             <a:avLst/>
@@ -4081,9 +4077,7 @@
             <a:srgbClr val="F8F8F8"/>
           </a:solidFill>
           <a:ln>
-            <a:solidFill>
-              <a:srgbClr val="D2D2D2"/>
-            </a:solidFill>
+            <a:noFill/>
           </a:ln>
         </p:spPr>
         <p:style>
@@ -4116,25 +4110,25 @@
         </p:nvSpPr>
         <p:spPr>
           <a:xfrm>
-            <a:off x="6053328" y="1197864"/>
-            <a:ext cx="1975104" cy="201168"/>
-          </a:xfrm>
-          <a:prstGeom prst="rect">
-            <a:avLst/>
-          </a:prstGeom>
-          <a:noFill/>
-        </p:spPr>
-        <p:txBody>
-          <a:bodyPr wrap="square" anchor="t" lIns="18288" rIns="18288">
-            <a:normAutofit/>
-          </a:bodyPr>
-          <a:lstStyle/>
-          <a:p>
-            <a:pPr algn="l"/>
+            <a:off x="6053328" y="1188720"/>
+            <a:ext cx="1975104" cy="219456"/>
+          </a:xfrm>
+          <a:prstGeom prst="rect">
+            <a:avLst/>
+          </a:prstGeom>
+          <a:noFill/>
+        </p:spPr>
+        <p:txBody>
+          <a:bodyPr wrap="square" anchor="t" lIns="45720" rIns="45720" tIns="18288" bIns="18288">
+            <a:normAutofit/>
+          </a:bodyPr>
+          <a:lstStyle/>
+          <a:p>
+            <a:pPr algn="ctr"/>
             <a:r>
               <a:rPr sz="1050" b="1">
                 <a:solidFill>
-                  <a:srgbClr val="000000"/>
+                  <a:srgbClr val="5F5F5F"/>
                 </a:solidFill>
                 <a:latin typeface="Aptos"/>
               </a:rPr>
@@ -4151,23 +4145,23 @@
         </p:nvSpPr>
         <p:spPr>
           <a:xfrm>
-            <a:off x="6053328" y="1463040"/>
-            <a:ext cx="1975104" cy="411480"/>
-          </a:xfrm>
-          <a:prstGeom prst="rect">
-            <a:avLst/>
-          </a:prstGeom>
-          <a:noFill/>
-        </p:spPr>
-        <p:txBody>
-          <a:bodyPr wrap="square" anchor="t" lIns="18288" rIns="18288">
-            <a:normAutofit/>
-          </a:bodyPr>
-          <a:lstStyle/>
-          <a:p>
-            <a:pPr algn="l"/>
-            <a:r>
-              <a:rPr sz="2100" b="1">
+            <a:off x="6053328" y="1453896"/>
+            <a:ext cx="1975104" cy="329184"/>
+          </a:xfrm>
+          <a:prstGeom prst="rect">
+            <a:avLst/>
+          </a:prstGeom>
+          <a:noFill/>
+        </p:spPr>
+        <p:txBody>
+          <a:bodyPr wrap="square" anchor="t" lIns="45720" rIns="45720" tIns="18288" bIns="18288">
+            <a:normAutofit/>
+          </a:bodyPr>
+          <a:lstStyle/>
+          <a:p>
+            <a:pPr algn="ctr"/>
+            <a:r>
+              <a:rPr sz="1800" b="1">
                 <a:solidFill>
                   <a:srgbClr val="000000"/>
                 </a:solidFill>
@@ -4186,25 +4180,25 @@
         </p:nvSpPr>
         <p:spPr>
           <a:xfrm>
-            <a:off x="6053328" y="1892807"/>
-            <a:ext cx="1975104" cy="228600"/>
-          </a:xfrm>
-          <a:prstGeom prst="rect">
-            <a:avLst/>
-          </a:prstGeom>
-          <a:noFill/>
-        </p:spPr>
-        <p:txBody>
-          <a:bodyPr wrap="square" anchor="t" lIns="18288" rIns="18288">
-            <a:normAutofit/>
-          </a:bodyPr>
-          <a:lstStyle/>
-          <a:p>
-            <a:pPr algn="l"/>
-            <a:r>
-              <a:rPr sz="919" b="0">
-                <a:solidFill>
-                  <a:srgbClr val="000000"/>
+            <a:off x="6053328" y="1847088"/>
+            <a:ext cx="1975104" cy="246888"/>
+          </a:xfrm>
+          <a:prstGeom prst="rect">
+            <a:avLst/>
+          </a:prstGeom>
+          <a:noFill/>
+        </p:spPr>
+        <p:txBody>
+          <a:bodyPr wrap="square" anchor="t" lIns="45720" rIns="45720" tIns="18288" bIns="18288">
+            <a:normAutofit/>
+          </a:bodyPr>
+          <a:lstStyle/>
+          <a:p>
+            <a:pPr algn="ctr"/>
+            <a:r>
+              <a:rPr sz="860" b="0">
+                <a:solidFill>
+                  <a:srgbClr val="5F5F5F"/>
                 </a:solidFill>
                 <a:latin typeface="Aptos"/>
               </a:rPr>
@@ -4222,7 +4216,7 @@
         <p:spPr>
           <a:xfrm>
             <a:off x="8549640" y="1097280"/>
-            <a:ext cx="2194560" cy="960120"/>
+            <a:ext cx="2194560" cy="1078992"/>
           </a:xfrm>
           <a:prstGeom prst="roundRect">
             <a:avLst/>
@@ -4231,9 +4225,7 @@
             <a:srgbClr val="F8F8F8"/>
           </a:solidFill>
           <a:ln>
-            <a:solidFill>
-              <a:srgbClr val="D2D2D2"/>
-            </a:solidFill>
+            <a:noFill/>
           </a:ln>
         </p:spPr>
         <p:style>
@@ -4266,25 +4258,25 @@
         </p:nvSpPr>
         <p:spPr>
           <a:xfrm>
-            <a:off x="8659367" y="1197864"/>
-            <a:ext cx="1975104" cy="201168"/>
-          </a:xfrm>
-          <a:prstGeom prst="rect">
-            <a:avLst/>
-          </a:prstGeom>
-          <a:noFill/>
-        </p:spPr>
-        <p:txBody>
-          <a:bodyPr wrap="square" anchor="t" lIns="18288" rIns="18288">
-            <a:normAutofit/>
-          </a:bodyPr>
-          <a:lstStyle/>
-          <a:p>
-            <a:pPr algn="l"/>
+            <a:off x="8659368" y="1188720"/>
+            <a:ext cx="1975104" cy="219456"/>
+          </a:xfrm>
+          <a:prstGeom prst="rect">
+            <a:avLst/>
+          </a:prstGeom>
+          <a:noFill/>
+        </p:spPr>
+        <p:txBody>
+          <a:bodyPr wrap="square" anchor="t" lIns="45720" rIns="45720" tIns="18288" bIns="18288">
+            <a:normAutofit/>
+          </a:bodyPr>
+          <a:lstStyle/>
+          <a:p>
+            <a:pPr algn="ctr"/>
             <a:r>
               <a:rPr sz="1050" b="1">
                 <a:solidFill>
-                  <a:srgbClr val="000000"/>
+                  <a:srgbClr val="5F5F5F"/>
                 </a:solidFill>
                 <a:latin typeface="Aptos"/>
               </a:rPr>
@@ -4301,23 +4293,23 @@
         </p:nvSpPr>
         <p:spPr>
           <a:xfrm>
-            <a:off x="8659367" y="1463040"/>
-            <a:ext cx="1975104" cy="411480"/>
-          </a:xfrm>
-          <a:prstGeom prst="rect">
-            <a:avLst/>
-          </a:prstGeom>
-          <a:noFill/>
-        </p:spPr>
-        <p:txBody>
-          <a:bodyPr wrap="square" anchor="t" lIns="18288" rIns="18288">
-            <a:normAutofit/>
-          </a:bodyPr>
-          <a:lstStyle/>
-          <a:p>
-            <a:pPr algn="l"/>
-            <a:r>
-              <a:rPr sz="2100" b="1">
+            <a:off x="8659368" y="1453896"/>
+            <a:ext cx="1975104" cy="329184"/>
+          </a:xfrm>
+          <a:prstGeom prst="rect">
+            <a:avLst/>
+          </a:prstGeom>
+          <a:noFill/>
+        </p:spPr>
+        <p:txBody>
+          <a:bodyPr wrap="square" anchor="t" lIns="45720" rIns="45720" tIns="18288" bIns="18288">
+            <a:normAutofit/>
+          </a:bodyPr>
+          <a:lstStyle/>
+          <a:p>
+            <a:pPr algn="ctr"/>
+            <a:r>
+              <a:rPr sz="1800" b="1">
                 <a:solidFill>
                   <a:srgbClr val="000000"/>
                 </a:solidFill>
@@ -4336,25 +4328,25 @@
         </p:nvSpPr>
         <p:spPr>
           <a:xfrm>
-            <a:off x="8659367" y="1892807"/>
-            <a:ext cx="1975104" cy="228600"/>
-          </a:xfrm>
-          <a:prstGeom prst="rect">
-            <a:avLst/>
-          </a:prstGeom>
-          <a:noFill/>
-        </p:spPr>
-        <p:txBody>
-          <a:bodyPr wrap="square" anchor="t" lIns="18288" rIns="18288">
-            <a:normAutofit/>
-          </a:bodyPr>
-          <a:lstStyle/>
-          <a:p>
-            <a:pPr algn="l"/>
-            <a:r>
-              <a:rPr sz="919" b="0">
-                <a:solidFill>
-                  <a:srgbClr val="000000"/>
+            <a:off x="8659368" y="1847088"/>
+            <a:ext cx="1975104" cy="246888"/>
+          </a:xfrm>
+          <a:prstGeom prst="rect">
+            <a:avLst/>
+          </a:prstGeom>
+          <a:noFill/>
+        </p:spPr>
+        <p:txBody>
+          <a:bodyPr wrap="square" anchor="t" lIns="45720" rIns="45720" tIns="18288" bIns="18288">
+            <a:normAutofit/>
+          </a:bodyPr>
+          <a:lstStyle/>
+          <a:p>
+            <a:pPr algn="ctr"/>
+            <a:r>
+              <a:rPr sz="860" b="0">
+                <a:solidFill>
+                  <a:srgbClr val="5F5F5F"/>
                 </a:solidFill>
                 <a:latin typeface="Aptos"/>
               </a:rPr>
@@ -4771,8 +4763,8 @@
         </p:nvSpPr>
         <p:spPr>
           <a:xfrm>
-            <a:off x="6446520" y="5440680"/>
-            <a:ext cx="2057400" cy="822960"/>
+            <a:off x="6446520" y="5376672"/>
+            <a:ext cx="2057400" cy="1115568"/>
           </a:xfrm>
           <a:prstGeom prst="roundRect">
             <a:avLst/>
@@ -4781,9 +4773,7 @@
             <a:srgbClr val="F8F8F8"/>
           </a:solidFill>
           <a:ln>
-            <a:solidFill>
-              <a:srgbClr val="D2D2D2"/>
-            </a:solidFill>
+            <a:noFill/>
           </a:ln>
         </p:spPr>
         <p:style>
@@ -4816,25 +4806,25 @@
         </p:nvSpPr>
         <p:spPr>
           <a:xfrm>
-            <a:off x="6556248" y="5541264"/>
-            <a:ext cx="1837943" cy="201168"/>
-          </a:xfrm>
-          <a:prstGeom prst="rect">
-            <a:avLst/>
-          </a:prstGeom>
-          <a:noFill/>
-        </p:spPr>
-        <p:txBody>
-          <a:bodyPr wrap="square" anchor="t" lIns="18288" rIns="18288">
-            <a:normAutofit/>
-          </a:bodyPr>
-          <a:lstStyle/>
-          <a:p>
-            <a:pPr algn="l"/>
+            <a:off x="6556248" y="5468112"/>
+            <a:ext cx="1837944" cy="219456"/>
+          </a:xfrm>
+          <a:prstGeom prst="rect">
+            <a:avLst/>
+          </a:prstGeom>
+          <a:noFill/>
+        </p:spPr>
+        <p:txBody>
+          <a:bodyPr wrap="square" anchor="t" lIns="45720" rIns="45720" tIns="18288" bIns="18288">
+            <a:normAutofit/>
+          </a:bodyPr>
+          <a:lstStyle/>
+          <a:p>
+            <a:pPr algn="ctr"/>
             <a:r>
               <a:rPr sz="1050" b="1">
                 <a:solidFill>
-                  <a:srgbClr val="000000"/>
+                  <a:srgbClr val="5F5F5F"/>
                 </a:solidFill>
                 <a:latin typeface="Aptos"/>
               </a:rPr>
@@ -4851,23 +4841,23 @@
         </p:nvSpPr>
         <p:spPr>
           <a:xfrm>
-            <a:off x="6556248" y="5806440"/>
-            <a:ext cx="1837943" cy="411480"/>
-          </a:xfrm>
-          <a:prstGeom prst="rect">
-            <a:avLst/>
-          </a:prstGeom>
-          <a:noFill/>
-        </p:spPr>
-        <p:txBody>
-          <a:bodyPr wrap="square" anchor="t" lIns="18288" rIns="18288">
-            <a:normAutofit/>
-          </a:bodyPr>
-          <a:lstStyle/>
-          <a:p>
-            <a:pPr algn="l"/>
-            <a:r>
-              <a:rPr sz="2100" b="1">
+            <a:off x="6556248" y="5733288"/>
+            <a:ext cx="1837944" cy="329184"/>
+          </a:xfrm>
+          <a:prstGeom prst="rect">
+            <a:avLst/>
+          </a:prstGeom>
+          <a:noFill/>
+        </p:spPr>
+        <p:txBody>
+          <a:bodyPr wrap="square" anchor="t" lIns="45720" rIns="45720" tIns="18288" bIns="18288">
+            <a:normAutofit/>
+          </a:bodyPr>
+          <a:lstStyle/>
+          <a:p>
+            <a:pPr algn="ctr"/>
+            <a:r>
+              <a:rPr sz="1800" b="1">
                 <a:solidFill>
                   <a:srgbClr val="000000"/>
                 </a:solidFill>
@@ -4886,25 +4876,25 @@
         </p:nvSpPr>
         <p:spPr>
           <a:xfrm>
-            <a:off x="6556248" y="6236208"/>
-            <a:ext cx="1837943" cy="228600"/>
-          </a:xfrm>
-          <a:prstGeom prst="rect">
-            <a:avLst/>
-          </a:prstGeom>
-          <a:noFill/>
-        </p:spPr>
-        <p:txBody>
-          <a:bodyPr wrap="square" anchor="t" lIns="18288" rIns="18288">
-            <a:normAutofit/>
-          </a:bodyPr>
-          <a:lstStyle/>
-          <a:p>
-            <a:pPr algn="l"/>
-            <a:r>
-              <a:rPr sz="919" b="0">
-                <a:solidFill>
-                  <a:srgbClr val="000000"/>
+            <a:off x="6556248" y="6126480"/>
+            <a:ext cx="1837944" cy="246888"/>
+          </a:xfrm>
+          <a:prstGeom prst="rect">
+            <a:avLst/>
+          </a:prstGeom>
+          <a:noFill/>
+        </p:spPr>
+        <p:txBody>
+          <a:bodyPr wrap="square" anchor="t" lIns="45720" rIns="45720" tIns="18288" bIns="18288">
+            <a:normAutofit/>
+          </a:bodyPr>
+          <a:lstStyle/>
+          <a:p>
+            <a:pPr algn="ctr"/>
+            <a:r>
+              <a:rPr sz="860" b="0">
+                <a:solidFill>
+                  <a:srgbClr val="5F5F5F"/>
                 </a:solidFill>
                 <a:latin typeface="Aptos"/>
               </a:rPr>
@@ -4921,8 +4911,8 @@
         </p:nvSpPr>
         <p:spPr>
           <a:xfrm>
-            <a:off x="8823960" y="5440680"/>
-            <a:ext cx="2057400" cy="822960"/>
+            <a:off x="8823960" y="5376672"/>
+            <a:ext cx="2057400" cy="1115568"/>
           </a:xfrm>
           <a:prstGeom prst="roundRect">
             <a:avLst/>
@@ -4931,9 +4921,7 @@
             <a:srgbClr val="F8F8F8"/>
           </a:solidFill>
           <a:ln>
-            <a:solidFill>
-              <a:srgbClr val="D2D2D2"/>
-            </a:solidFill>
+            <a:noFill/>
           </a:ln>
         </p:spPr>
         <p:style>
@@ -4966,25 +4954,25 @@
         </p:nvSpPr>
         <p:spPr>
           <a:xfrm>
-            <a:off x="8933688" y="5541264"/>
-            <a:ext cx="1837943" cy="201168"/>
-          </a:xfrm>
-          <a:prstGeom prst="rect">
-            <a:avLst/>
-          </a:prstGeom>
-          <a:noFill/>
-        </p:spPr>
-        <p:txBody>
-          <a:bodyPr wrap="square" anchor="t" lIns="18288" rIns="18288">
-            <a:normAutofit/>
-          </a:bodyPr>
-          <a:lstStyle/>
-          <a:p>
-            <a:pPr algn="l"/>
+            <a:off x="8933688" y="5468112"/>
+            <a:ext cx="1837944" cy="219456"/>
+          </a:xfrm>
+          <a:prstGeom prst="rect">
+            <a:avLst/>
+          </a:prstGeom>
+          <a:noFill/>
+        </p:spPr>
+        <p:txBody>
+          <a:bodyPr wrap="square" anchor="t" lIns="45720" rIns="45720" tIns="18288" bIns="18288">
+            <a:normAutofit/>
+          </a:bodyPr>
+          <a:lstStyle/>
+          <a:p>
+            <a:pPr algn="ctr"/>
             <a:r>
               <a:rPr sz="1050" b="1">
                 <a:solidFill>
-                  <a:srgbClr val="000000"/>
+                  <a:srgbClr val="5F5F5F"/>
                 </a:solidFill>
                 <a:latin typeface="Aptos"/>
               </a:rPr>
@@ -5001,23 +4989,23 @@
         </p:nvSpPr>
         <p:spPr>
           <a:xfrm>
-            <a:off x="8933688" y="5806440"/>
-            <a:ext cx="1837943" cy="411480"/>
-          </a:xfrm>
-          <a:prstGeom prst="rect">
-            <a:avLst/>
-          </a:prstGeom>
-          <a:noFill/>
-        </p:spPr>
-        <p:txBody>
-          <a:bodyPr wrap="square" anchor="t" lIns="18288" rIns="18288">
-            <a:normAutofit/>
-          </a:bodyPr>
-          <a:lstStyle/>
-          <a:p>
-            <a:pPr algn="l"/>
-            <a:r>
-              <a:rPr sz="2100" b="1">
+            <a:off x="8933688" y="5733288"/>
+            <a:ext cx="1837944" cy="329184"/>
+          </a:xfrm>
+          <a:prstGeom prst="rect">
+            <a:avLst/>
+          </a:prstGeom>
+          <a:noFill/>
+        </p:spPr>
+        <p:txBody>
+          <a:bodyPr wrap="square" anchor="t" lIns="45720" rIns="45720" tIns="18288" bIns="18288">
+            <a:normAutofit/>
+          </a:bodyPr>
+          <a:lstStyle/>
+          <a:p>
+            <a:pPr algn="ctr"/>
+            <a:r>
+              <a:rPr sz="1800" b="1">
                 <a:solidFill>
                   <a:srgbClr val="000000"/>
                 </a:solidFill>
@@ -5036,25 +5024,25 @@
         </p:nvSpPr>
         <p:spPr>
           <a:xfrm>
-            <a:off x="8933688" y="6236208"/>
-            <a:ext cx="1837943" cy="228600"/>
-          </a:xfrm>
-          <a:prstGeom prst="rect">
-            <a:avLst/>
-          </a:prstGeom>
-          <a:noFill/>
-        </p:spPr>
-        <p:txBody>
-          <a:bodyPr wrap="square" anchor="t" lIns="18288" rIns="18288">
-            <a:normAutofit/>
-          </a:bodyPr>
-          <a:lstStyle/>
-          <a:p>
-            <a:pPr algn="l"/>
-            <a:r>
-              <a:rPr sz="919" b="0">
-                <a:solidFill>
-                  <a:srgbClr val="000000"/>
+            <a:off x="8933688" y="6126480"/>
+            <a:ext cx="1837944" cy="246888"/>
+          </a:xfrm>
+          <a:prstGeom prst="rect">
+            <a:avLst/>
+          </a:prstGeom>
+          <a:noFill/>
+        </p:spPr>
+        <p:txBody>
+          <a:bodyPr wrap="square" anchor="t" lIns="45720" rIns="45720" tIns="18288" bIns="18288">
+            <a:normAutofit/>
+          </a:bodyPr>
+          <a:lstStyle/>
+          <a:p>
+            <a:pPr algn="ctr"/>
+            <a:r>
+              <a:rPr sz="860" b="0">
+                <a:solidFill>
+                  <a:srgbClr val="5F5F5F"/>
                 </a:solidFill>
                 <a:latin typeface="Aptos"/>
               </a:rPr>
@@ -5337,8 +5325,8 @@
         </p:nvSpPr>
         <p:spPr>
           <a:xfrm>
-            <a:off x="777240" y="5166360"/>
-            <a:ext cx="2194560" cy="868680"/>
+            <a:off x="777240" y="5047488"/>
+            <a:ext cx="2194560" cy="1115568"/>
           </a:xfrm>
           <a:prstGeom prst="roundRect">
             <a:avLst/>
@@ -5347,9 +5335,7 @@
             <a:srgbClr val="F8F8F8"/>
           </a:solidFill>
           <a:ln>
-            <a:solidFill>
-              <a:srgbClr val="D2D2D2"/>
-            </a:solidFill>
+            <a:noFill/>
           </a:ln>
         </p:spPr>
         <p:style>
@@ -5382,25 +5368,25 @@
         </p:nvSpPr>
         <p:spPr>
           <a:xfrm>
-            <a:off x="886968" y="5266944"/>
-            <a:ext cx="1975104" cy="201168"/>
-          </a:xfrm>
-          <a:prstGeom prst="rect">
-            <a:avLst/>
-          </a:prstGeom>
-          <a:noFill/>
-        </p:spPr>
-        <p:txBody>
-          <a:bodyPr wrap="square" anchor="t" lIns="18288" rIns="18288">
-            <a:normAutofit/>
-          </a:bodyPr>
-          <a:lstStyle/>
-          <a:p>
-            <a:pPr algn="l"/>
+            <a:off x="886968" y="5138928"/>
+            <a:ext cx="1975104" cy="219456"/>
+          </a:xfrm>
+          <a:prstGeom prst="rect">
+            <a:avLst/>
+          </a:prstGeom>
+          <a:noFill/>
+        </p:spPr>
+        <p:txBody>
+          <a:bodyPr wrap="square" anchor="t" lIns="45720" rIns="45720" tIns="18288" bIns="18288">
+            <a:normAutofit/>
+          </a:bodyPr>
+          <a:lstStyle/>
+          <a:p>
+            <a:pPr algn="ctr"/>
             <a:r>
               <a:rPr sz="1050" b="1">
                 <a:solidFill>
-                  <a:srgbClr val="000000"/>
+                  <a:srgbClr val="5F5F5F"/>
                 </a:solidFill>
                 <a:latin typeface="Aptos"/>
               </a:rPr>
@@ -5417,23 +5403,23 @@
         </p:nvSpPr>
         <p:spPr>
           <a:xfrm>
-            <a:off x="886968" y="5532120"/>
-            <a:ext cx="1975104" cy="411480"/>
-          </a:xfrm>
-          <a:prstGeom prst="rect">
-            <a:avLst/>
-          </a:prstGeom>
-          <a:noFill/>
-        </p:spPr>
-        <p:txBody>
-          <a:bodyPr wrap="square" anchor="t" lIns="18288" rIns="18288">
-            <a:normAutofit/>
-          </a:bodyPr>
-          <a:lstStyle/>
-          <a:p>
-            <a:pPr algn="l"/>
-            <a:r>
-              <a:rPr sz="2100" b="1">
+            <a:off x="886968" y="5404104"/>
+            <a:ext cx="1975104" cy="329184"/>
+          </a:xfrm>
+          <a:prstGeom prst="rect">
+            <a:avLst/>
+          </a:prstGeom>
+          <a:noFill/>
+        </p:spPr>
+        <p:txBody>
+          <a:bodyPr wrap="square" anchor="t" lIns="45720" rIns="45720" tIns="18288" bIns="18288">
+            <a:normAutofit/>
+          </a:bodyPr>
+          <a:lstStyle/>
+          <a:p>
+            <a:pPr algn="ctr"/>
+            <a:r>
+              <a:rPr sz="1800" b="1">
                 <a:solidFill>
                   <a:srgbClr val="000000"/>
                 </a:solidFill>
@@ -5452,25 +5438,25 @@
         </p:nvSpPr>
         <p:spPr>
           <a:xfrm>
-            <a:off x="886968" y="5961888"/>
-            <a:ext cx="1975104" cy="228600"/>
-          </a:xfrm>
-          <a:prstGeom prst="rect">
-            <a:avLst/>
-          </a:prstGeom>
-          <a:noFill/>
-        </p:spPr>
-        <p:txBody>
-          <a:bodyPr wrap="square" anchor="t" lIns="18288" rIns="18288">
-            <a:normAutofit/>
-          </a:bodyPr>
-          <a:lstStyle/>
-          <a:p>
-            <a:pPr algn="l"/>
-            <a:r>
-              <a:rPr sz="919" b="0">
-                <a:solidFill>
-                  <a:srgbClr val="000000"/>
+            <a:off x="886968" y="5797296"/>
+            <a:ext cx="1975104" cy="246888"/>
+          </a:xfrm>
+          <a:prstGeom prst="rect">
+            <a:avLst/>
+          </a:prstGeom>
+          <a:noFill/>
+        </p:spPr>
+        <p:txBody>
+          <a:bodyPr wrap="square" anchor="t" lIns="45720" rIns="45720" tIns="18288" bIns="18288">
+            <a:normAutofit/>
+          </a:bodyPr>
+          <a:lstStyle/>
+          <a:p>
+            <a:pPr algn="ctr"/>
+            <a:r>
+              <a:rPr sz="860" b="0">
+                <a:solidFill>
+                  <a:srgbClr val="5F5F5F"/>
                 </a:solidFill>
                 <a:latin typeface="Aptos"/>
               </a:rPr>
@@ -5487,8 +5473,8 @@
         </p:nvSpPr>
         <p:spPr>
           <a:xfrm>
-            <a:off x="3246120" y="5166360"/>
-            <a:ext cx="2194560" cy="868680"/>
+            <a:off x="3246120" y="5047488"/>
+            <a:ext cx="2194560" cy="1115568"/>
           </a:xfrm>
           <a:prstGeom prst="roundRect">
             <a:avLst/>
@@ -5497,9 +5483,7 @@
             <a:srgbClr val="F8F8F8"/>
           </a:solidFill>
           <a:ln>
-            <a:solidFill>
-              <a:srgbClr val="D2D2D2"/>
-            </a:solidFill>
+            <a:noFill/>
           </a:ln>
         </p:spPr>
         <p:style>
@@ -5532,25 +5516,25 @@
         </p:nvSpPr>
         <p:spPr>
           <a:xfrm>
-            <a:off x="3355848" y="5266944"/>
-            <a:ext cx="1975104" cy="201168"/>
-          </a:xfrm>
-          <a:prstGeom prst="rect">
-            <a:avLst/>
-          </a:prstGeom>
-          <a:noFill/>
-        </p:spPr>
-        <p:txBody>
-          <a:bodyPr wrap="square" anchor="t" lIns="18288" rIns="18288">
-            <a:normAutofit/>
-          </a:bodyPr>
-          <a:lstStyle/>
-          <a:p>
-            <a:pPr algn="l"/>
+            <a:off x="3355848" y="5138928"/>
+            <a:ext cx="1975104" cy="219456"/>
+          </a:xfrm>
+          <a:prstGeom prst="rect">
+            <a:avLst/>
+          </a:prstGeom>
+          <a:noFill/>
+        </p:spPr>
+        <p:txBody>
+          <a:bodyPr wrap="square" anchor="t" lIns="45720" rIns="45720" tIns="18288" bIns="18288">
+            <a:normAutofit/>
+          </a:bodyPr>
+          <a:lstStyle/>
+          <a:p>
+            <a:pPr algn="ctr"/>
             <a:r>
               <a:rPr sz="1050" b="1">
                 <a:solidFill>
-                  <a:srgbClr val="000000"/>
+                  <a:srgbClr val="5F5F5F"/>
                 </a:solidFill>
                 <a:latin typeface="Aptos"/>
               </a:rPr>
@@ -5567,23 +5551,23 @@
         </p:nvSpPr>
         <p:spPr>
           <a:xfrm>
-            <a:off x="3355848" y="5532120"/>
-            <a:ext cx="1975104" cy="411480"/>
-          </a:xfrm>
-          <a:prstGeom prst="rect">
-            <a:avLst/>
-          </a:prstGeom>
-          <a:noFill/>
-        </p:spPr>
-        <p:txBody>
-          <a:bodyPr wrap="square" anchor="t" lIns="18288" rIns="18288">
-            <a:normAutofit/>
-          </a:bodyPr>
-          <a:lstStyle/>
-          <a:p>
-            <a:pPr algn="l"/>
-            <a:r>
-              <a:rPr sz="2100" b="1">
+            <a:off x="3355848" y="5404104"/>
+            <a:ext cx="1975104" cy="329184"/>
+          </a:xfrm>
+          <a:prstGeom prst="rect">
+            <a:avLst/>
+          </a:prstGeom>
+          <a:noFill/>
+        </p:spPr>
+        <p:txBody>
+          <a:bodyPr wrap="square" anchor="t" lIns="45720" rIns="45720" tIns="18288" bIns="18288">
+            <a:normAutofit/>
+          </a:bodyPr>
+          <a:lstStyle/>
+          <a:p>
+            <a:pPr algn="ctr"/>
+            <a:r>
+              <a:rPr sz="1800" b="1">
                 <a:solidFill>
                   <a:srgbClr val="000000"/>
                 </a:solidFill>
@@ -5602,25 +5586,25 @@
         </p:nvSpPr>
         <p:spPr>
           <a:xfrm>
-            <a:off x="3355848" y="5961888"/>
-            <a:ext cx="1975104" cy="228600"/>
-          </a:xfrm>
-          <a:prstGeom prst="rect">
-            <a:avLst/>
-          </a:prstGeom>
-          <a:noFill/>
-        </p:spPr>
-        <p:txBody>
-          <a:bodyPr wrap="square" anchor="t" lIns="18288" rIns="18288">
-            <a:normAutofit/>
-          </a:bodyPr>
-          <a:lstStyle/>
-          <a:p>
-            <a:pPr algn="l"/>
-            <a:r>
-              <a:rPr sz="919" b="0">
-                <a:solidFill>
-                  <a:srgbClr val="000000"/>
+            <a:off x="3355848" y="5797296"/>
+            <a:ext cx="1975104" cy="246888"/>
+          </a:xfrm>
+          <a:prstGeom prst="rect">
+            <a:avLst/>
+          </a:prstGeom>
+          <a:noFill/>
+        </p:spPr>
+        <p:txBody>
+          <a:bodyPr wrap="square" anchor="t" lIns="45720" rIns="45720" tIns="18288" bIns="18288">
+            <a:normAutofit/>
+          </a:bodyPr>
+          <a:lstStyle/>
+          <a:p>
+            <a:pPr algn="ctr"/>
+            <a:r>
+              <a:rPr sz="860" b="0">
+                <a:solidFill>
+                  <a:srgbClr val="5F5F5F"/>
                 </a:solidFill>
                 <a:latin typeface="Aptos"/>
               </a:rPr>
@@ -5637,8 +5621,8 @@
         </p:nvSpPr>
         <p:spPr>
           <a:xfrm>
-            <a:off x="5715000" y="5166360"/>
-            <a:ext cx="2194560" cy="868680"/>
+            <a:off x="5715000" y="5047488"/>
+            <a:ext cx="2194560" cy="1115568"/>
           </a:xfrm>
           <a:prstGeom prst="roundRect">
             <a:avLst/>
@@ -5647,9 +5631,7 @@
             <a:srgbClr val="F8F8F8"/>
           </a:solidFill>
           <a:ln>
-            <a:solidFill>
-              <a:srgbClr val="D2D2D2"/>
-            </a:solidFill>
+            <a:noFill/>
           </a:ln>
         </p:spPr>
         <p:style>
@@ -5682,25 +5664,25 @@
         </p:nvSpPr>
         <p:spPr>
           <a:xfrm>
-            <a:off x="5824728" y="5266944"/>
-            <a:ext cx="1975104" cy="201168"/>
-          </a:xfrm>
-          <a:prstGeom prst="rect">
-            <a:avLst/>
-          </a:prstGeom>
-          <a:noFill/>
-        </p:spPr>
-        <p:txBody>
-          <a:bodyPr wrap="square" anchor="t" lIns="18288" rIns="18288">
-            <a:normAutofit/>
-          </a:bodyPr>
-          <a:lstStyle/>
-          <a:p>
-            <a:pPr algn="l"/>
+            <a:off x="5824728" y="5138928"/>
+            <a:ext cx="1975104" cy="219456"/>
+          </a:xfrm>
+          <a:prstGeom prst="rect">
+            <a:avLst/>
+          </a:prstGeom>
+          <a:noFill/>
+        </p:spPr>
+        <p:txBody>
+          <a:bodyPr wrap="square" anchor="t" lIns="45720" rIns="45720" tIns="18288" bIns="18288">
+            <a:normAutofit/>
+          </a:bodyPr>
+          <a:lstStyle/>
+          <a:p>
+            <a:pPr algn="ctr"/>
             <a:r>
               <a:rPr sz="1050" b="1">
                 <a:solidFill>
-                  <a:srgbClr val="000000"/>
+                  <a:srgbClr val="5F5F5F"/>
                 </a:solidFill>
                 <a:latin typeface="Aptos"/>
               </a:rPr>
@@ -5717,23 +5699,23 @@
         </p:nvSpPr>
         <p:spPr>
           <a:xfrm>
-            <a:off x="5824728" y="5532120"/>
-            <a:ext cx="1975104" cy="411480"/>
-          </a:xfrm>
-          <a:prstGeom prst="rect">
-            <a:avLst/>
-          </a:prstGeom>
-          <a:noFill/>
-        </p:spPr>
-        <p:txBody>
-          <a:bodyPr wrap="square" anchor="t" lIns="18288" rIns="18288">
-            <a:normAutofit/>
-          </a:bodyPr>
-          <a:lstStyle/>
-          <a:p>
-            <a:pPr algn="l"/>
-            <a:r>
-              <a:rPr sz="2100" b="1">
+            <a:off x="5824728" y="5404104"/>
+            <a:ext cx="1975104" cy="329184"/>
+          </a:xfrm>
+          <a:prstGeom prst="rect">
+            <a:avLst/>
+          </a:prstGeom>
+          <a:noFill/>
+        </p:spPr>
+        <p:txBody>
+          <a:bodyPr wrap="square" anchor="t" lIns="45720" rIns="45720" tIns="18288" bIns="18288">
+            <a:normAutofit/>
+          </a:bodyPr>
+          <a:lstStyle/>
+          <a:p>
+            <a:pPr algn="ctr"/>
+            <a:r>
+              <a:rPr sz="1800" b="1">
                 <a:solidFill>
                   <a:srgbClr val="000000"/>
                 </a:solidFill>
@@ -5752,25 +5734,25 @@
         </p:nvSpPr>
         <p:spPr>
           <a:xfrm>
-            <a:off x="5824728" y="5961888"/>
-            <a:ext cx="1975104" cy="228600"/>
-          </a:xfrm>
-          <a:prstGeom prst="rect">
-            <a:avLst/>
-          </a:prstGeom>
-          <a:noFill/>
-        </p:spPr>
-        <p:txBody>
-          <a:bodyPr wrap="square" anchor="t" lIns="18288" rIns="18288">
-            <a:normAutofit/>
-          </a:bodyPr>
-          <a:lstStyle/>
-          <a:p>
-            <a:pPr algn="l"/>
-            <a:r>
-              <a:rPr sz="919" b="0">
-                <a:solidFill>
-                  <a:srgbClr val="000000"/>
+            <a:off x="5824728" y="5797296"/>
+            <a:ext cx="1975104" cy="246888"/>
+          </a:xfrm>
+          <a:prstGeom prst="rect">
+            <a:avLst/>
+          </a:prstGeom>
+          <a:noFill/>
+        </p:spPr>
+        <p:txBody>
+          <a:bodyPr wrap="square" anchor="t" lIns="45720" rIns="45720" tIns="18288" bIns="18288">
+            <a:normAutofit/>
+          </a:bodyPr>
+          <a:lstStyle/>
+          <a:p>
+            <a:pPr algn="ctr"/>
+            <a:r>
+              <a:rPr sz="860" b="0">
+                <a:solidFill>
+                  <a:srgbClr val="5F5F5F"/>
                 </a:solidFill>
                 <a:latin typeface="Aptos"/>
               </a:rPr>
@@ -5787,8 +5769,8 @@
         </p:nvSpPr>
         <p:spPr>
           <a:xfrm>
-            <a:off x="8183879" y="5166360"/>
-            <a:ext cx="2194560" cy="868680"/>
+            <a:off x="8183879" y="5047488"/>
+            <a:ext cx="2194560" cy="1115568"/>
           </a:xfrm>
           <a:prstGeom prst="roundRect">
             <a:avLst/>
@@ -5797,9 +5779,7 @@
             <a:srgbClr val="F8F8F8"/>
           </a:solidFill>
           <a:ln>
-            <a:solidFill>
-              <a:srgbClr val="D2D2D2"/>
-            </a:solidFill>
+            <a:noFill/>
           </a:ln>
         </p:spPr>
         <p:style>
@@ -5832,25 +5812,25 @@
         </p:nvSpPr>
         <p:spPr>
           <a:xfrm>
-            <a:off x="8293607" y="5266944"/>
-            <a:ext cx="1975104" cy="201168"/>
-          </a:xfrm>
-          <a:prstGeom prst="rect">
-            <a:avLst/>
-          </a:prstGeom>
-          <a:noFill/>
-        </p:spPr>
-        <p:txBody>
-          <a:bodyPr wrap="square" anchor="t" lIns="18288" rIns="18288">
-            <a:normAutofit/>
-          </a:bodyPr>
-          <a:lstStyle/>
-          <a:p>
-            <a:pPr algn="l"/>
+            <a:off x="8293607" y="5138928"/>
+            <a:ext cx="1975104" cy="219456"/>
+          </a:xfrm>
+          <a:prstGeom prst="rect">
+            <a:avLst/>
+          </a:prstGeom>
+          <a:noFill/>
+        </p:spPr>
+        <p:txBody>
+          <a:bodyPr wrap="square" anchor="t" lIns="45720" rIns="45720" tIns="18288" bIns="18288">
+            <a:normAutofit/>
+          </a:bodyPr>
+          <a:lstStyle/>
+          <a:p>
+            <a:pPr algn="ctr"/>
             <a:r>
               <a:rPr sz="1050" b="1">
                 <a:solidFill>
-                  <a:srgbClr val="000000"/>
+                  <a:srgbClr val="5F5F5F"/>
                 </a:solidFill>
                 <a:latin typeface="Aptos"/>
               </a:rPr>
@@ -5867,23 +5847,23 @@
         </p:nvSpPr>
         <p:spPr>
           <a:xfrm>
-            <a:off x="8293607" y="5532120"/>
-            <a:ext cx="1975104" cy="411480"/>
-          </a:xfrm>
-          <a:prstGeom prst="rect">
-            <a:avLst/>
-          </a:prstGeom>
-          <a:noFill/>
-        </p:spPr>
-        <p:txBody>
-          <a:bodyPr wrap="square" anchor="t" lIns="18288" rIns="18288">
-            <a:normAutofit/>
-          </a:bodyPr>
-          <a:lstStyle/>
-          <a:p>
-            <a:pPr algn="l"/>
-            <a:r>
-              <a:rPr sz="2100" b="1">
+            <a:off x="8293607" y="5404104"/>
+            <a:ext cx="1975104" cy="329184"/>
+          </a:xfrm>
+          <a:prstGeom prst="rect">
+            <a:avLst/>
+          </a:prstGeom>
+          <a:noFill/>
+        </p:spPr>
+        <p:txBody>
+          <a:bodyPr wrap="square" anchor="t" lIns="45720" rIns="45720" tIns="18288" bIns="18288">
+            <a:normAutofit/>
+          </a:bodyPr>
+          <a:lstStyle/>
+          <a:p>
+            <a:pPr algn="ctr"/>
+            <a:r>
+              <a:rPr sz="1800" b="1">
                 <a:solidFill>
                   <a:srgbClr val="000000"/>
                 </a:solidFill>
@@ -5902,25 +5882,25 @@
         </p:nvSpPr>
         <p:spPr>
           <a:xfrm>
-            <a:off x="8293607" y="5961888"/>
-            <a:ext cx="1975104" cy="228600"/>
-          </a:xfrm>
-          <a:prstGeom prst="rect">
-            <a:avLst/>
-          </a:prstGeom>
-          <a:noFill/>
-        </p:spPr>
-        <p:txBody>
-          <a:bodyPr wrap="square" anchor="t" lIns="18288" rIns="18288">
-            <a:normAutofit/>
-          </a:bodyPr>
-          <a:lstStyle/>
-          <a:p>
-            <a:pPr algn="l"/>
-            <a:r>
-              <a:rPr sz="919" b="0">
-                <a:solidFill>
-                  <a:srgbClr val="000000"/>
+            <a:off x="8293607" y="5797296"/>
+            <a:ext cx="1975104" cy="246888"/>
+          </a:xfrm>
+          <a:prstGeom prst="rect">
+            <a:avLst/>
+          </a:prstGeom>
+          <a:noFill/>
+        </p:spPr>
+        <p:txBody>
+          <a:bodyPr wrap="square" anchor="t" lIns="45720" rIns="45720" tIns="18288" bIns="18288">
+            <a:normAutofit/>
+          </a:bodyPr>
+          <a:lstStyle/>
+          <a:p>
+            <a:pPr algn="ctr"/>
+            <a:r>
+              <a:rPr sz="860" b="0">
+                <a:solidFill>
+                  <a:srgbClr val="5F5F5F"/>
                 </a:solidFill>
                 <a:latin typeface="Aptos"/>
               </a:rPr>
@@ -6484,7 +6464,7 @@
         <p:spPr>
           <a:xfrm>
             <a:off x="731520" y="1600200"/>
-            <a:ext cx="2423160" cy="868680"/>
+            <a:ext cx="2423160" cy="1078992"/>
           </a:xfrm>
           <a:prstGeom prst="roundRect">
             <a:avLst/>
@@ -6493,9 +6473,7 @@
             <a:srgbClr val="F8F8F8"/>
           </a:solidFill>
           <a:ln>
-            <a:solidFill>
-              <a:srgbClr val="D2D2D2"/>
-            </a:solidFill>
+            <a:noFill/>
           </a:ln>
         </p:spPr>
         <p:style>
@@ -6528,25 +6506,25 @@
         </p:nvSpPr>
         <p:spPr>
           <a:xfrm>
-            <a:off x="841248" y="1700784"/>
-            <a:ext cx="2203704" cy="201168"/>
-          </a:xfrm>
-          <a:prstGeom prst="rect">
-            <a:avLst/>
-          </a:prstGeom>
-          <a:noFill/>
-        </p:spPr>
-        <p:txBody>
-          <a:bodyPr wrap="square" anchor="t" lIns="18288" rIns="18288">
-            <a:normAutofit/>
-          </a:bodyPr>
-          <a:lstStyle/>
-          <a:p>
-            <a:pPr algn="l"/>
+            <a:off x="841248" y="1691640"/>
+            <a:ext cx="2203704" cy="219456"/>
+          </a:xfrm>
+          <a:prstGeom prst="rect">
+            <a:avLst/>
+          </a:prstGeom>
+          <a:noFill/>
+        </p:spPr>
+        <p:txBody>
+          <a:bodyPr wrap="square" anchor="ctr" lIns="45720" rIns="45720" tIns="18288" bIns="18288">
+            <a:normAutofit/>
+          </a:bodyPr>
+          <a:lstStyle/>
+          <a:p>
+            <a:pPr algn="ctr"/>
             <a:r>
               <a:rPr sz="1050" b="1">
                 <a:solidFill>
-                  <a:srgbClr val="000000"/>
+                  <a:srgbClr val="5F5F5F"/>
                 </a:solidFill>
                 <a:latin typeface="Aptos"/>
               </a:rPr>
@@ -6563,23 +6541,23 @@
         </p:nvSpPr>
         <p:spPr>
           <a:xfrm>
-            <a:off x="841248" y="1965960"/>
-            <a:ext cx="2203704" cy="411480"/>
-          </a:xfrm>
-          <a:prstGeom prst="rect">
-            <a:avLst/>
-          </a:prstGeom>
-          <a:noFill/>
-        </p:spPr>
-        <p:txBody>
-          <a:bodyPr wrap="square" anchor="t" lIns="18288" rIns="18288">
-            <a:normAutofit/>
-          </a:bodyPr>
-          <a:lstStyle/>
-          <a:p>
-            <a:pPr algn="l"/>
-            <a:r>
-              <a:rPr sz="2100" b="1">
+            <a:off x="841248" y="1956816"/>
+            <a:ext cx="2203704" cy="329184"/>
+          </a:xfrm>
+          <a:prstGeom prst="rect">
+            <a:avLst/>
+          </a:prstGeom>
+          <a:noFill/>
+        </p:spPr>
+        <p:txBody>
+          <a:bodyPr wrap="square" anchor="ctr" lIns="45720" rIns="45720" tIns="18288" bIns="18288">
+            <a:normAutofit/>
+          </a:bodyPr>
+          <a:lstStyle/>
+          <a:p>
+            <a:pPr algn="ctr"/>
+            <a:r>
+              <a:rPr sz="1800" b="1">
                 <a:solidFill>
                   <a:srgbClr val="000000"/>
                 </a:solidFill>
@@ -6598,29 +6576,29 @@
         </p:nvSpPr>
         <p:spPr>
           <a:xfrm>
-            <a:off x="841248" y="2395728"/>
-            <a:ext cx="2203704" cy="228600"/>
-          </a:xfrm>
-          <a:prstGeom prst="rect">
-            <a:avLst/>
-          </a:prstGeom>
-          <a:noFill/>
-        </p:spPr>
-        <p:txBody>
-          <a:bodyPr wrap="square" anchor="t" lIns="18288" rIns="18288">
-            <a:normAutofit/>
-          </a:bodyPr>
-          <a:lstStyle/>
-          <a:p>
-            <a:pPr algn="l"/>
-            <a:r>
-              <a:rPr sz="919" b="0">
-                <a:solidFill>
-                  <a:srgbClr val="000000"/>
-                </a:solidFill>
-                <a:latin typeface="Aptos"/>
-              </a:rPr>
-              <a:t>modelo entregable</a:t>
+            <a:off x="841248" y="2350008"/>
+            <a:ext cx="2203704" cy="246888"/>
+          </a:xfrm>
+          <a:prstGeom prst="rect">
+            <a:avLst/>
+          </a:prstGeom>
+          <a:noFill/>
+        </p:spPr>
+        <p:txBody>
+          <a:bodyPr wrap="square" anchor="ctr" lIns="45720" rIns="45720" tIns="18288" bIns="18288">
+            <a:normAutofit/>
+          </a:bodyPr>
+          <a:lstStyle/>
+          <a:p>
+            <a:pPr algn="ctr"/>
+            <a:r>
+              <a:rPr sz="860" b="0">
+                <a:solidFill>
+                  <a:srgbClr val="5F5F5F"/>
+                </a:solidFill>
+                <a:latin typeface="Aptos"/>
+              </a:rPr>
+              <a:t>Kaggle</a:t>
             </a:r>
           </a:p>
         </p:txBody>
@@ -6634,7 +6612,7 @@
         <p:spPr>
           <a:xfrm>
             <a:off x="3429000" y="1600200"/>
-            <a:ext cx="2423160" cy="868680"/>
+            <a:ext cx="2423160" cy="1078992"/>
           </a:xfrm>
           <a:prstGeom prst="roundRect">
             <a:avLst/>
@@ -6643,9 +6621,7 @@
             <a:srgbClr val="F8F8F8"/>
           </a:solidFill>
           <a:ln>
-            <a:solidFill>
-              <a:srgbClr val="D2D2D2"/>
-            </a:solidFill>
+            <a:noFill/>
           </a:ln>
         </p:spPr>
         <p:style>
@@ -6678,29 +6654,29 @@
         </p:nvSpPr>
         <p:spPr>
           <a:xfrm>
-            <a:off x="3538728" y="1700784"/>
-            <a:ext cx="2203704" cy="201168"/>
-          </a:xfrm>
-          <a:prstGeom prst="rect">
-            <a:avLst/>
-          </a:prstGeom>
-          <a:noFill/>
-        </p:spPr>
-        <p:txBody>
-          <a:bodyPr wrap="square" anchor="t" lIns="18288" rIns="18288">
-            <a:normAutofit/>
-          </a:bodyPr>
-          <a:lstStyle/>
-          <a:p>
-            <a:pPr algn="l"/>
+            <a:off x="3538728" y="1691640"/>
+            <a:ext cx="2203704" cy="219456"/>
+          </a:xfrm>
+          <a:prstGeom prst="rect">
+            <a:avLst/>
+          </a:prstGeom>
+          <a:noFill/>
+        </p:spPr>
+        <p:txBody>
+          <a:bodyPr wrap="square" anchor="ctr" lIns="45720" rIns="45720" tIns="18288" bIns="18288">
+            <a:normAutofit/>
+          </a:bodyPr>
+          <a:lstStyle/>
+          <a:p>
+            <a:pPr algn="ctr"/>
             <a:r>
               <a:rPr sz="1050" b="1">
                 <a:solidFill>
-                  <a:srgbClr val="000000"/>
-                </a:solidFill>
-                <a:latin typeface="Aptos"/>
-              </a:rPr>
-              <a:t>CatBoost</a:t>
+                  <a:srgbClr val="5F5F5F"/>
+                </a:solidFill>
+                <a:latin typeface="Aptos"/>
+              </a:rPr>
+              <a:t>Base predictiva</a:t>
             </a:r>
           </a:p>
         </p:txBody>
@@ -6713,29 +6689,29 @@
         </p:nvSpPr>
         <p:spPr>
           <a:xfrm>
-            <a:off x="3538728" y="1965960"/>
-            <a:ext cx="2203704" cy="411480"/>
-          </a:xfrm>
-          <a:prstGeom prst="rect">
-            <a:avLst/>
-          </a:prstGeom>
-          <a:noFill/>
-        </p:spPr>
-        <p:txBody>
-          <a:bodyPr wrap="square" anchor="t" lIns="18288" rIns="18288">
-            <a:normAutofit/>
-          </a:bodyPr>
-          <a:lstStyle/>
-          <a:p>
-            <a:pPr algn="l"/>
-            <a:r>
-              <a:rPr sz="2100" b="1">
-                <a:solidFill>
-                  <a:srgbClr val="000000"/>
-                </a:solidFill>
-                <a:latin typeface="Aptos"/>
-              </a:rPr>
-              <a:t>top 60</a:t>
+            <a:off x="3538728" y="1956816"/>
+            <a:ext cx="2203704" cy="329184"/>
+          </a:xfrm>
+          <a:prstGeom prst="rect">
+            <a:avLst/>
+          </a:prstGeom>
+          <a:noFill/>
+        </p:spPr>
+        <p:txBody>
+          <a:bodyPr wrap="square" anchor="ctr" lIns="45720" rIns="45720" tIns="18288" bIns="18288">
+            <a:normAutofit/>
+          </a:bodyPr>
+          <a:lstStyle/>
+          <a:p>
+            <a:pPr algn="ctr"/>
+            <a:r>
+              <a:rPr sz="1800" b="1">
+                <a:solidFill>
+                  <a:srgbClr val="000000"/>
+                </a:solidFill>
+                <a:latin typeface="Aptos"/>
+              </a:rPr>
+              <a:t>CatBoost + ET</a:t>
             </a:r>
           </a:p>
         </p:txBody>
@@ -6748,29 +6724,29 @@
         </p:nvSpPr>
         <p:spPr>
           <a:xfrm>
-            <a:off x="3538728" y="2395728"/>
-            <a:ext cx="2203704" cy="228600"/>
-          </a:xfrm>
-          <a:prstGeom prst="rect">
-            <a:avLst/>
-          </a:prstGeom>
-          <a:noFill/>
-        </p:spPr>
-        <p:txBody>
-          <a:bodyPr wrap="square" anchor="t" lIns="18288" rIns="18288">
-            <a:normAutofit/>
-          </a:bodyPr>
-          <a:lstStyle/>
-          <a:p>
-            <a:pPr algn="l"/>
-            <a:r>
-              <a:rPr sz="919" b="0">
-                <a:solidFill>
-                  <a:srgbClr val="000000"/>
-                </a:solidFill>
-                <a:latin typeface="Aptos"/>
-              </a:rPr>
-              <a:t>66 features finales</a:t>
+            <a:off x="3538728" y="2350008"/>
+            <a:ext cx="2203704" cy="246888"/>
+          </a:xfrm>
+          <a:prstGeom prst="rect">
+            <a:avLst/>
+          </a:prstGeom>
+          <a:noFill/>
+        </p:spPr>
+        <p:txBody>
+          <a:bodyPr wrap="square" anchor="ctr" lIns="45720" rIns="45720" tIns="18288" bIns="18288">
+            <a:normAutofit/>
+          </a:bodyPr>
+          <a:lstStyle/>
+          <a:p>
+            <a:pPr algn="ctr"/>
+            <a:r>
+              <a:rPr sz="860" b="0">
+                <a:solidFill>
+                  <a:srgbClr val="5F5F5F"/>
+                </a:solidFill>
+                <a:latin typeface="Aptos"/>
+              </a:rPr>
+              <a:t>ranking preservado</a:t>
             </a:r>
           </a:p>
         </p:txBody>
@@ -6784,7 +6760,7 @@
         <p:spPr>
           <a:xfrm>
             <a:off x="6126480" y="1600200"/>
-            <a:ext cx="2423160" cy="868680"/>
+            <a:ext cx="2423160" cy="1078992"/>
           </a:xfrm>
           <a:prstGeom prst="roundRect">
             <a:avLst/>
@@ -6793,9 +6769,7 @@
             <a:srgbClr val="F8F8F8"/>
           </a:solidFill>
           <a:ln>
-            <a:solidFill>
-              <a:srgbClr val="D2D2D2"/>
-            </a:solidFill>
+            <a:noFill/>
           </a:ln>
         </p:spPr>
         <p:style>
@@ -6828,29 +6802,29 @@
         </p:nvSpPr>
         <p:spPr>
           <a:xfrm>
-            <a:off x="6236208" y="1700784"/>
-            <a:ext cx="2203704" cy="201168"/>
-          </a:xfrm>
-          <a:prstGeom prst="rect">
-            <a:avLst/>
-          </a:prstGeom>
-          <a:noFill/>
-        </p:spPr>
-        <p:txBody>
-          <a:bodyPr wrap="square" anchor="t" lIns="18288" rIns="18288">
-            <a:normAutofit/>
-          </a:bodyPr>
-          <a:lstStyle/>
-          <a:p>
-            <a:pPr algn="l"/>
+            <a:off x="6236208" y="1691640"/>
+            <a:ext cx="2203704" cy="219456"/>
+          </a:xfrm>
+          <a:prstGeom prst="rect">
+            <a:avLst/>
+          </a:prstGeom>
+          <a:noFill/>
+        </p:spPr>
+        <p:txBody>
+          <a:bodyPr wrap="square" anchor="ctr" lIns="45720" rIns="45720" tIns="18288" bIns="18288">
+            <a:normAutofit/>
+          </a:bodyPr>
+          <a:lstStyle/>
+          <a:p>
+            <a:pPr algn="ctr"/>
             <a:r>
               <a:rPr sz="1050" b="1">
                 <a:solidFill>
-                  <a:srgbClr val="000000"/>
-                </a:solidFill>
-                <a:latin typeface="Aptos"/>
-              </a:rPr>
-              <a:t>ExtraTrees</a:t>
+                  <a:srgbClr val="5F5F5F"/>
+                </a:solidFill>
+                <a:latin typeface="Aptos"/>
+              </a:rPr>
+              <a:t>Ajuste final</a:t>
             </a:r>
           </a:p>
         </p:txBody>
@@ -6863,29 +6837,29 @@
         </p:nvSpPr>
         <p:spPr>
           <a:xfrm>
-            <a:off x="6236208" y="1965960"/>
-            <a:ext cx="2203704" cy="411480"/>
-          </a:xfrm>
-          <a:prstGeom prst="rect">
-            <a:avLst/>
-          </a:prstGeom>
-          <a:noFill/>
-        </p:spPr>
-        <p:txBody>
-          <a:bodyPr wrap="square" anchor="t" lIns="18288" rIns="18288">
-            <a:normAutofit/>
-          </a:bodyPr>
-          <a:lstStyle/>
-          <a:p>
-            <a:pPr algn="l"/>
-            <a:r>
-              <a:rPr sz="2100" b="1">
-                <a:solidFill>
-                  <a:srgbClr val="000000"/>
-                </a:solidFill>
-                <a:latin typeface="Aptos"/>
-              </a:rPr>
-              <a:t>3 variantes</a:t>
+            <a:off x="6236208" y="1956816"/>
+            <a:ext cx="2203704" cy="329184"/>
+          </a:xfrm>
+          <a:prstGeom prst="rect">
+            <a:avLst/>
+          </a:prstGeom>
+          <a:noFill/>
+        </p:spPr>
+        <p:txBody>
+          <a:bodyPr wrap="square" anchor="ctr" lIns="45720" rIns="45720" tIns="18288" bIns="18288">
+            <a:normAutofit/>
+          </a:bodyPr>
+          <a:lstStyle/>
+          <a:p>
+            <a:pPr algn="ctr"/>
+            <a:r>
+              <a:rPr sz="1800" b="1">
+                <a:solidFill>
+                  <a:srgbClr val="000000"/>
+                </a:solidFill>
+                <a:latin typeface="Aptos"/>
+              </a:rPr>
+              <a:t>2 reglas</a:t>
             </a:r>
           </a:p>
         </p:txBody>
@@ -6898,29 +6872,29 @@
         </p:nvSpPr>
         <p:spPr>
           <a:xfrm>
-            <a:off x="6236208" y="2395728"/>
-            <a:ext cx="2203704" cy="228600"/>
-          </a:xfrm>
-          <a:prstGeom prst="rect">
-            <a:avLst/>
-          </a:prstGeom>
-          <a:noFill/>
-        </p:spPr>
-        <p:txBody>
-          <a:bodyPr wrap="square" anchor="t" lIns="18288" rIns="18288">
-            <a:normAutofit/>
-          </a:bodyPr>
-          <a:lstStyle/>
-          <a:p>
-            <a:pPr algn="l"/>
-            <a:r>
-              <a:rPr sz="919" b="0">
-                <a:solidFill>
-                  <a:srgbClr val="000000"/>
-                </a:solidFill>
-                <a:latin typeface="Aptos"/>
-              </a:rPr>
-              <a:t>45, 70 y 100 features</a:t>
+            <a:off x="6236208" y="2350008"/>
+            <a:ext cx="2203704" cy="246888"/>
+          </a:xfrm>
+          <a:prstGeom prst="rect">
+            <a:avLst/>
+          </a:prstGeom>
+          <a:noFill/>
+        </p:spPr>
+        <p:txBody>
+          <a:bodyPr wrap="square" anchor="ctr" lIns="45720" rIns="45720" tIns="18288" bIns="18288">
+            <a:normAutofit/>
+          </a:bodyPr>
+          <a:lstStyle/>
+          <a:p>
+            <a:pPr algn="ctr"/>
+            <a:r>
+              <a:rPr sz="860" b="0">
+                <a:solidFill>
+                  <a:srgbClr val="5F5F5F"/>
+                </a:solidFill>
+                <a:latin typeface="Aptos"/>
+              </a:rPr>
+              <a:t>subgéneros</a:t>
             </a:r>
           </a:p>
         </p:txBody>
@@ -6934,7 +6908,7 @@
         <p:spPr>
           <a:xfrm>
             <a:off x="8823960" y="1600200"/>
-            <a:ext cx="2423160" cy="868680"/>
+            <a:ext cx="2423160" cy="1078992"/>
           </a:xfrm>
           <a:prstGeom prst="roundRect">
             <a:avLst/>
@@ -6943,9 +6917,7 @@
             <a:srgbClr val="F8F8F8"/>
           </a:solidFill>
           <a:ln>
-            <a:solidFill>
-              <a:srgbClr val="D2D2D2"/>
-            </a:solidFill>
+            <a:noFill/>
           </a:ln>
         </p:spPr>
         <p:style>
@@ -6978,29 +6950,29 @@
         </p:nvSpPr>
         <p:spPr>
           <a:xfrm>
-            <a:off x="8933688" y="1700784"/>
-            <a:ext cx="2203704" cy="201168"/>
-          </a:xfrm>
-          <a:prstGeom prst="rect">
-            <a:avLst/>
-          </a:prstGeom>
-          <a:noFill/>
-        </p:spPr>
-        <p:txBody>
-          <a:bodyPr wrap="square" anchor="t" lIns="18288" rIns="18288">
-            <a:normAutofit/>
-          </a:bodyPr>
-          <a:lstStyle/>
-          <a:p>
-            <a:pPr algn="l"/>
+            <a:off x="8933688" y="1691640"/>
+            <a:ext cx="2203704" cy="219456"/>
+          </a:xfrm>
+          <a:prstGeom prst="rect">
+            <a:avLst/>
+          </a:prstGeom>
+          <a:noFill/>
+        </p:spPr>
+        <p:txBody>
+          <a:bodyPr wrap="square" anchor="ctr" lIns="45720" rIns="45720" tIns="18288" bIns="18288">
+            <a:normAutofit/>
+          </a:bodyPr>
+          <a:lstStyle/>
+          <a:p>
+            <a:pPr algn="ctr"/>
             <a:r>
               <a:rPr sz="1050" b="1">
                 <a:solidFill>
-                  <a:srgbClr val="000000"/>
-                </a:solidFill>
-                <a:latin typeface="Aptos"/>
-              </a:rPr>
-              <a:t>Postproceso</a:t>
+                  <a:srgbClr val="5F5F5F"/>
+                </a:solidFill>
+                <a:latin typeface="Aptos"/>
+              </a:rPr>
+              <a:t>Rol del modelo</a:t>
             </a:r>
           </a:p>
         </p:txBody>
@@ -7013,29 +6985,29 @@
         </p:nvSpPr>
         <p:spPr>
           <a:xfrm>
-            <a:off x="8933688" y="1965960"/>
-            <a:ext cx="2203704" cy="411480"/>
-          </a:xfrm>
-          <a:prstGeom prst="rect">
-            <a:avLst/>
-          </a:prstGeom>
-          <a:noFill/>
-        </p:spPr>
-        <p:txBody>
-          <a:bodyPr wrap="square" anchor="t" lIns="18288" rIns="18288">
-            <a:normAutofit/>
-          </a:bodyPr>
-          <a:lstStyle/>
-          <a:p>
-            <a:pPr algn="l"/>
-            <a:r>
-              <a:rPr sz="2100" b="1">
-                <a:solidFill>
-                  <a:srgbClr val="000000"/>
-                </a:solidFill>
-                <a:latin typeface="Aptos"/>
-              </a:rPr>
-              <a:t>2 reglas</a:t>
+            <a:off x="8933688" y="1956816"/>
+            <a:ext cx="2203704" cy="329184"/>
+          </a:xfrm>
+          <a:prstGeom prst="rect">
+            <a:avLst/>
+          </a:prstGeom>
+          <a:noFill/>
+        </p:spPr>
+        <p:txBody>
+          <a:bodyPr wrap="square" anchor="ctr" lIns="45720" rIns="45720" tIns="18288" bIns="18288">
+            <a:normAutofit/>
+          </a:bodyPr>
+          <a:lstStyle/>
+          <a:p>
+            <a:pPr algn="ctr"/>
+            <a:r>
+              <a:rPr sz="1800" b="1">
+                <a:solidFill>
+                  <a:srgbClr val="000000"/>
+                </a:solidFill>
+                <a:latin typeface="Aptos"/>
+              </a:rPr>
+              <a:t>Entregable</a:t>
             </a:r>
           </a:p>
         </p:txBody>
@@ -7048,29 +7020,29 @@
         </p:nvSpPr>
         <p:spPr>
           <a:xfrm>
-            <a:off x="8933688" y="2395728"/>
-            <a:ext cx="2203704" cy="228600"/>
-          </a:xfrm>
-          <a:prstGeom prst="rect">
-            <a:avLst/>
-          </a:prstGeom>
-          <a:noFill/>
-        </p:spPr>
-        <p:txBody>
-          <a:bodyPr wrap="square" anchor="t" lIns="18288" rIns="18288">
-            <a:normAutofit/>
-          </a:bodyPr>
-          <a:lstStyle/>
-          <a:p>
-            <a:pPr algn="l"/>
-            <a:r>
-              <a:rPr sz="919" b="0">
-                <a:solidFill>
-                  <a:srgbClr val="000000"/>
-                </a:solidFill>
-                <a:latin typeface="Aptos"/>
-              </a:rPr>
-              <a:t>subgéneros</a:t>
+            <a:off x="8933688" y="2350008"/>
+            <a:ext cx="2203704" cy="246888"/>
+          </a:xfrm>
+          <a:prstGeom prst="rect">
+            <a:avLst/>
+          </a:prstGeom>
+          <a:noFill/>
+        </p:spPr>
+        <p:txBody>
+          <a:bodyPr wrap="square" anchor="ctr" lIns="45720" rIns="45720" tIns="18288" bIns="18288">
+            <a:normAutofit/>
+          </a:bodyPr>
+          <a:lstStyle/>
+          <a:p>
+            <a:pPr algn="ctr"/>
+            <a:r>
+              <a:rPr sz="860" b="0">
+                <a:solidFill>
+                  <a:srgbClr val="5F5F5F"/>
+                </a:solidFill>
+                <a:latin typeface="Aptos"/>
+              </a:rPr>
+              <a:t>pipeline reproducible</a:t>
             </a:r>
           </a:p>
         </p:txBody>
@@ -7350,7 +7322,7 @@
         <p:spPr>
           <a:xfrm>
             <a:off x="731520" y="1097280"/>
-            <a:ext cx="2606040" cy="914400"/>
+            <a:ext cx="2606040" cy="1115568"/>
           </a:xfrm>
           <a:prstGeom prst="roundRect">
             <a:avLst/>
@@ -7359,9 +7331,7 @@
             <a:srgbClr val="F8F8F8"/>
           </a:solidFill>
           <a:ln>
-            <a:solidFill>
-              <a:srgbClr val="D2D2D2"/>
-            </a:solidFill>
+            <a:noFill/>
           </a:ln>
         </p:spPr>
         <p:style>
@@ -7394,25 +7364,25 @@
         </p:nvSpPr>
         <p:spPr>
           <a:xfrm>
-            <a:off x="841248" y="1197864"/>
-            <a:ext cx="2386584" cy="201168"/>
-          </a:xfrm>
-          <a:prstGeom prst="rect">
-            <a:avLst/>
-          </a:prstGeom>
-          <a:noFill/>
-        </p:spPr>
-        <p:txBody>
-          <a:bodyPr wrap="square" anchor="t" lIns="18288" rIns="18288">
-            <a:normAutofit/>
-          </a:bodyPr>
-          <a:lstStyle/>
-          <a:p>
-            <a:pPr algn="l"/>
+            <a:off x="841248" y="1188720"/>
+            <a:ext cx="2386584" cy="219456"/>
+          </a:xfrm>
+          <a:prstGeom prst="rect">
+            <a:avLst/>
+          </a:prstGeom>
+          <a:noFill/>
+        </p:spPr>
+        <p:txBody>
+          <a:bodyPr wrap="square" anchor="ctr" lIns="45720" rIns="45720" tIns="18288" bIns="18288">
+            <a:normAutofit/>
+          </a:bodyPr>
+          <a:lstStyle/>
+          <a:p>
+            <a:pPr algn="ctr"/>
             <a:r>
               <a:rPr sz="1050" b="1">
                 <a:solidFill>
-                  <a:srgbClr val="000000"/>
+                  <a:srgbClr val="5F5F5F"/>
                 </a:solidFill>
                 <a:latin typeface="Aptos"/>
               </a:rPr>
@@ -7429,23 +7399,23 @@
         </p:nvSpPr>
         <p:spPr>
           <a:xfrm>
-            <a:off x="841248" y="1463040"/>
-            <a:ext cx="2386584" cy="411480"/>
-          </a:xfrm>
-          <a:prstGeom prst="rect">
-            <a:avLst/>
-          </a:prstGeom>
-          <a:noFill/>
-        </p:spPr>
-        <p:txBody>
-          <a:bodyPr wrap="square" anchor="t" lIns="18288" rIns="18288">
-            <a:normAutofit/>
-          </a:bodyPr>
-          <a:lstStyle/>
-          <a:p>
-            <a:pPr algn="l"/>
-            <a:r>
-              <a:rPr sz="2100" b="1">
+            <a:off x="841248" y="1453896"/>
+            <a:ext cx="2386584" cy="329184"/>
+          </a:xfrm>
+          <a:prstGeom prst="rect">
+            <a:avLst/>
+          </a:prstGeom>
+          <a:noFill/>
+        </p:spPr>
+        <p:txBody>
+          <a:bodyPr wrap="square" anchor="ctr" lIns="45720" rIns="45720" tIns="18288" bIns="18288">
+            <a:normAutofit/>
+          </a:bodyPr>
+          <a:lstStyle/>
+          <a:p>
+            <a:pPr algn="ctr"/>
+            <a:r>
+              <a:rPr sz="1800" b="1">
                 <a:solidFill>
                   <a:srgbClr val="000000"/>
                 </a:solidFill>
@@ -7464,29 +7434,29 @@
         </p:nvSpPr>
         <p:spPr>
           <a:xfrm>
-            <a:off x="841248" y="1892807"/>
-            <a:ext cx="2386584" cy="228600"/>
-          </a:xfrm>
-          <a:prstGeom prst="rect">
-            <a:avLst/>
-          </a:prstGeom>
-          <a:noFill/>
-        </p:spPr>
-        <p:txBody>
-          <a:bodyPr wrap="square" anchor="t" lIns="18288" rIns="18288">
-            <a:normAutofit/>
-          </a:bodyPr>
-          <a:lstStyle/>
-          <a:p>
-            <a:pPr algn="l"/>
-            <a:r>
-              <a:rPr sz="919" b="0">
-                <a:solidFill>
-                  <a:srgbClr val="000000"/>
-                </a:solidFill>
-                <a:latin typeface="Aptos"/>
-              </a:rPr>
-              <a:t>mejor score</a:t>
+            <a:off x="841248" y="1847088"/>
+            <a:ext cx="2386584" cy="246888"/>
+          </a:xfrm>
+          <a:prstGeom prst="rect">
+            <a:avLst/>
+          </a:prstGeom>
+          <a:noFill/>
+        </p:spPr>
+        <p:txBody>
+          <a:bodyPr wrap="square" anchor="ctr" lIns="45720" rIns="45720" tIns="18288" bIns="18288">
+            <a:normAutofit/>
+          </a:bodyPr>
+          <a:lstStyle/>
+          <a:p>
+            <a:pPr algn="ctr"/>
+            <a:r>
+              <a:rPr sz="860" b="0">
+                <a:solidFill>
+                  <a:srgbClr val="5F5F5F"/>
+                </a:solidFill>
+                <a:latin typeface="Aptos"/>
+              </a:rPr>
+              <a:t>Kaggle</a:t>
             </a:r>
           </a:p>
         </p:txBody>
@@ -7500,7 +7470,7 @@
         <p:spPr>
           <a:xfrm>
             <a:off x="3657600" y="1097280"/>
-            <a:ext cx="2606040" cy="914400"/>
+            <a:ext cx="2606040" cy="1115568"/>
           </a:xfrm>
           <a:prstGeom prst="roundRect">
             <a:avLst/>
@@ -7509,9 +7479,7 @@
             <a:srgbClr val="F8F8F8"/>
           </a:solidFill>
           <a:ln>
-            <a:solidFill>
-              <a:srgbClr val="D2D2D2"/>
-            </a:solidFill>
+            <a:noFill/>
           </a:ln>
         </p:spPr>
         <p:style>
@@ -7544,29 +7512,29 @@
         </p:nvSpPr>
         <p:spPr>
           <a:xfrm>
-            <a:off x="3767328" y="1197864"/>
-            <a:ext cx="2386584" cy="201168"/>
-          </a:xfrm>
-          <a:prstGeom prst="rect">
-            <a:avLst/>
-          </a:prstGeom>
-          <a:noFill/>
-        </p:spPr>
-        <p:txBody>
-          <a:bodyPr wrap="square" anchor="t" lIns="18288" rIns="18288">
-            <a:normAutofit/>
-          </a:bodyPr>
-          <a:lstStyle/>
-          <a:p>
-            <a:pPr algn="l"/>
+            <a:off x="3767328" y="1188720"/>
+            <a:ext cx="2386584" cy="219456"/>
+          </a:xfrm>
+          <a:prstGeom prst="rect">
+            <a:avLst/>
+          </a:prstGeom>
+          <a:noFill/>
+        </p:spPr>
+        <p:txBody>
+          <a:bodyPr wrap="square" anchor="ctr" lIns="45720" rIns="45720" tIns="18288" bIns="18288">
+            <a:normAutofit/>
+          </a:bodyPr>
+          <a:lstStyle/>
+          <a:p>
+            <a:pPr algn="ctr"/>
             <a:r>
               <a:rPr sz="1050" b="1">
                 <a:solidFill>
-                  <a:srgbClr val="000000"/>
-                </a:solidFill>
-                <a:latin typeface="Aptos"/>
-              </a:rPr>
-              <a:t>Base</a:t>
+                  <a:srgbClr val="5F5F5F"/>
+                </a:solidFill>
+                <a:latin typeface="Aptos"/>
+              </a:rPr>
+              <a:t>Base predictiva</a:t>
             </a:r>
           </a:p>
         </p:txBody>
@@ -7579,29 +7547,29 @@
         </p:nvSpPr>
         <p:spPr>
           <a:xfrm>
-            <a:off x="3767328" y="1463040"/>
-            <a:ext cx="2386584" cy="411480"/>
-          </a:xfrm>
-          <a:prstGeom prst="rect">
-            <a:avLst/>
-          </a:prstGeom>
-          <a:noFill/>
-        </p:spPr>
-        <p:txBody>
-          <a:bodyPr wrap="square" anchor="t" lIns="18288" rIns="18288">
-            <a:normAutofit/>
-          </a:bodyPr>
-          <a:lstStyle/>
-          <a:p>
-            <a:pPr algn="l"/>
-            <a:r>
-              <a:rPr sz="2100" b="1">
-                <a:solidFill>
-                  <a:srgbClr val="000000"/>
-                </a:solidFill>
-                <a:latin typeface="Aptos"/>
-              </a:rPr>
-              <a:t>submits</a:t>
+            <a:off x="3767328" y="1453896"/>
+            <a:ext cx="2386584" cy="329184"/>
+          </a:xfrm>
+          <a:prstGeom prst="rect">
+            <a:avLst/>
+          </a:prstGeom>
+          <a:noFill/>
+        </p:spPr>
+        <p:txBody>
+          <a:bodyPr wrap="square" anchor="ctr" lIns="45720" rIns="45720" tIns="18288" bIns="18288">
+            <a:normAutofit/>
+          </a:bodyPr>
+          <a:lstStyle/>
+          <a:p>
+            <a:pPr algn="ctr"/>
+            <a:r>
+              <a:rPr sz="1800" b="1">
+                <a:solidFill>
+                  <a:srgbClr val="000000"/>
+                </a:solidFill>
+                <a:latin typeface="Aptos"/>
+              </a:rPr>
+              <a:t>Submits previos</a:t>
             </a:r>
           </a:p>
         </p:txBody>
@@ -7614,29 +7582,29 @@
         </p:nvSpPr>
         <p:spPr>
           <a:xfrm>
-            <a:off x="3767328" y="1892807"/>
-            <a:ext cx="2386584" cy="228600"/>
-          </a:xfrm>
-          <a:prstGeom prst="rect">
-            <a:avLst/>
-          </a:prstGeom>
-          <a:noFill/>
-        </p:spPr>
-        <p:txBody>
-          <a:bodyPr wrap="square" anchor="t" lIns="18288" rIns="18288">
-            <a:normAutofit/>
-          </a:bodyPr>
-          <a:lstStyle/>
-          <a:p>
-            <a:pPr algn="l"/>
-            <a:r>
-              <a:rPr sz="919" b="0">
-                <a:solidFill>
-                  <a:srgbClr val="000000"/>
-                </a:solidFill>
-                <a:latin typeface="Aptos"/>
-              </a:rPr>
-              <a:t>predicciones previas</a:t>
+            <a:off x="3767328" y="1847088"/>
+            <a:ext cx="2386584" cy="246888"/>
+          </a:xfrm>
+          <a:prstGeom prst="rect">
+            <a:avLst/>
+          </a:prstGeom>
+          <a:noFill/>
+        </p:spPr>
+        <p:txBody>
+          <a:bodyPr wrap="square" anchor="ctr" lIns="45720" rIns="45720" tIns="18288" bIns="18288">
+            <a:normAutofit/>
+          </a:bodyPr>
+          <a:lstStyle/>
+          <a:p>
+            <a:pPr algn="ctr"/>
+            <a:r>
+              <a:rPr sz="860" b="0">
+                <a:solidFill>
+                  <a:srgbClr val="5F5F5F"/>
+                </a:solidFill>
+                <a:latin typeface="Aptos"/>
+              </a:rPr>
+              <a:t>predicciones históricas</a:t>
             </a:r>
           </a:p>
         </p:txBody>
@@ -7650,7 +7618,7 @@
         <p:spPr>
           <a:xfrm>
             <a:off x="6583680" y="1097280"/>
-            <a:ext cx="2606040" cy="914400"/>
+            <a:ext cx="2606040" cy="1115568"/>
           </a:xfrm>
           <a:prstGeom prst="roundRect">
             <a:avLst/>
@@ -7659,9 +7627,7 @@
             <a:srgbClr val="F8F8F8"/>
           </a:solidFill>
           <a:ln>
-            <a:solidFill>
-              <a:srgbClr val="D2D2D2"/>
-            </a:solidFill>
+            <a:noFill/>
           </a:ln>
         </p:spPr>
         <p:style>
@@ -7694,29 +7660,29 @@
         </p:nvSpPr>
         <p:spPr>
           <a:xfrm>
-            <a:off x="6693408" y="1197864"/>
-            <a:ext cx="2386584" cy="201168"/>
-          </a:xfrm>
-          <a:prstGeom prst="rect">
-            <a:avLst/>
-          </a:prstGeom>
-          <a:noFill/>
-        </p:spPr>
-        <p:txBody>
-          <a:bodyPr wrap="square" anchor="t" lIns="18288" rIns="18288">
-            <a:normAutofit/>
-          </a:bodyPr>
-          <a:lstStyle/>
-          <a:p>
-            <a:pPr algn="l"/>
+            <a:off x="6693408" y="1188720"/>
+            <a:ext cx="2386584" cy="219456"/>
+          </a:xfrm>
+          <a:prstGeom prst="rect">
+            <a:avLst/>
+          </a:prstGeom>
+          <a:noFill/>
+        </p:spPr>
+        <p:txBody>
+          <a:bodyPr wrap="square" anchor="ctr" lIns="45720" rIns="45720" tIns="18288" bIns="18288">
+            <a:normAutofit/>
+          </a:bodyPr>
+          <a:lstStyle/>
+          <a:p>
+            <a:pPr algn="ctr"/>
             <a:r>
               <a:rPr sz="1050" b="1">
                 <a:solidFill>
-                  <a:srgbClr val="000000"/>
-                </a:solidFill>
-                <a:latin typeface="Aptos"/>
-              </a:rPr>
-              <a:t>Calibración</a:t>
+                  <a:srgbClr val="5F5F5F"/>
+                </a:solidFill>
+                <a:latin typeface="Aptos"/>
+              </a:rPr>
+              <a:t>Ajuste final</a:t>
             </a:r>
           </a:p>
         </p:txBody>
@@ -7729,29 +7695,29 @@
         </p:nvSpPr>
         <p:spPr>
           <a:xfrm>
-            <a:off x="6693408" y="1463040"/>
-            <a:ext cx="2386584" cy="411480"/>
-          </a:xfrm>
-          <a:prstGeom prst="rect">
-            <a:avLst/>
-          </a:prstGeom>
-          <a:noFill/>
-        </p:spPr>
-        <p:txBody>
-          <a:bodyPr wrap="square" anchor="t" lIns="18288" rIns="18288">
-            <a:normAutofit/>
-          </a:bodyPr>
-          <a:lstStyle/>
-          <a:p>
-            <a:pPr algn="l"/>
-            <a:r>
-              <a:rPr sz="2100" b="1">
-                <a:solidFill>
-                  <a:srgbClr val="000000"/>
-                </a:solidFill>
-                <a:latin typeface="Aptos"/>
-              </a:rPr>
-              <a:t>scores</a:t>
+            <a:off x="6693408" y="1453896"/>
+            <a:ext cx="2386584" cy="329184"/>
+          </a:xfrm>
+          <a:prstGeom prst="rect">
+            <a:avLst/>
+          </a:prstGeom>
+          <a:noFill/>
+        </p:spPr>
+        <p:txBody>
+          <a:bodyPr wrap="square" anchor="ctr" lIns="45720" rIns="45720" tIns="18288" bIns="18288">
+            <a:normAutofit/>
+          </a:bodyPr>
+          <a:lstStyle/>
+          <a:p>
+            <a:pPr algn="ctr"/>
+            <a:r>
+              <a:rPr sz="1800" b="1">
+                <a:solidFill>
+                  <a:srgbClr val="000000"/>
+                </a:solidFill>
+                <a:latin typeface="Aptos"/>
+              </a:rPr>
+              <a:t>Solver LB</a:t>
             </a:r>
           </a:p>
         </p:txBody>
@@ -7764,29 +7730,29 @@
         </p:nvSpPr>
         <p:spPr>
           <a:xfrm>
-            <a:off x="6693408" y="1892807"/>
-            <a:ext cx="2386584" cy="228600"/>
-          </a:xfrm>
-          <a:prstGeom prst="rect">
-            <a:avLst/>
-          </a:prstGeom>
-          <a:noFill/>
-        </p:spPr>
-        <p:txBody>
-          <a:bodyPr wrap="square" anchor="t" lIns="18288" rIns="18288">
-            <a:normAutofit/>
-          </a:bodyPr>
-          <a:lstStyle/>
-          <a:p>
-            <a:pPr algn="l"/>
-            <a:r>
-              <a:rPr sz="919" b="0">
-                <a:solidFill>
-                  <a:srgbClr val="000000"/>
-                </a:solidFill>
-                <a:latin typeface="Aptos"/>
-              </a:rPr>
-              <a:t>leaderboard público</a:t>
+            <a:off x="6693408" y="1847088"/>
+            <a:ext cx="2386584" cy="246888"/>
+          </a:xfrm>
+          <a:prstGeom prst="rect">
+            <a:avLst/>
+          </a:prstGeom>
+          <a:noFill/>
+        </p:spPr>
+        <p:txBody>
+          <a:bodyPr wrap="square" anchor="ctr" lIns="45720" rIns="45720" tIns="18288" bIns="18288">
+            <a:normAutofit/>
+          </a:bodyPr>
+          <a:lstStyle/>
+          <a:p>
+            <a:pPr algn="ctr"/>
+            <a:r>
+              <a:rPr sz="860" b="0">
+                <a:solidFill>
+                  <a:srgbClr val="5F5F5F"/>
+                </a:solidFill>
+                <a:latin typeface="Aptos"/>
+              </a:rPr>
+              <a:t>calibración pública</a:t>
             </a:r>
           </a:p>
         </p:txBody>
@@ -7800,7 +7766,7 @@
         <p:spPr>
           <a:xfrm>
             <a:off x="9509760" y="1097280"/>
-            <a:ext cx="1965960" cy="914400"/>
+            <a:ext cx="1965960" cy="1115568"/>
           </a:xfrm>
           <a:prstGeom prst="roundRect">
             <a:avLst/>
@@ -7809,9 +7775,7 @@
             <a:srgbClr val="F8F8F8"/>
           </a:solidFill>
           <a:ln>
-            <a:solidFill>
-              <a:srgbClr val="D2D2D2"/>
-            </a:solidFill>
+            <a:noFill/>
           </a:ln>
         </p:spPr>
         <p:style>
@@ -7844,29 +7808,29 @@
         </p:nvSpPr>
         <p:spPr>
           <a:xfrm>
-            <a:off x="9619488" y="1197864"/>
-            <a:ext cx="1746504" cy="201168"/>
-          </a:xfrm>
-          <a:prstGeom prst="rect">
-            <a:avLst/>
-          </a:prstGeom>
-          <a:noFill/>
-        </p:spPr>
-        <p:txBody>
-          <a:bodyPr wrap="square" anchor="t" lIns="18288" rIns="18288">
-            <a:normAutofit/>
-          </a:bodyPr>
-          <a:lstStyle/>
-          <a:p>
-            <a:pPr algn="l"/>
+            <a:off x="9619488" y="1188720"/>
+            <a:ext cx="1746504" cy="219456"/>
+          </a:xfrm>
+          <a:prstGeom prst="rect">
+            <a:avLst/>
+          </a:prstGeom>
+          <a:noFill/>
+        </p:spPr>
+        <p:txBody>
+          <a:bodyPr wrap="square" anchor="ctr" lIns="45720" rIns="45720" tIns="18288" bIns="18288">
+            <a:normAutofit/>
+          </a:bodyPr>
+          <a:lstStyle/>
+          <a:p>
+            <a:pPr algn="ctr"/>
             <a:r>
               <a:rPr sz="1050" b="1">
                 <a:solidFill>
-                  <a:srgbClr val="000000"/>
-                </a:solidFill>
-                <a:latin typeface="Aptos"/>
-              </a:rPr>
-              <a:t>Salida</a:t>
+                  <a:srgbClr val="5F5F5F"/>
+                </a:solidFill>
+                <a:latin typeface="Aptos"/>
+              </a:rPr>
+              <a:t>Rol del modelo</a:t>
             </a:r>
           </a:p>
         </p:txBody>
@@ -7879,29 +7843,29 @@
         </p:nvSpPr>
         <p:spPr>
           <a:xfrm>
-            <a:off x="9619488" y="1463040"/>
-            <a:ext cx="1746504" cy="411480"/>
-          </a:xfrm>
-          <a:prstGeom prst="rect">
-            <a:avLst/>
-          </a:prstGeom>
-          <a:noFill/>
-        </p:spPr>
-        <p:txBody>
-          <a:bodyPr wrap="square" anchor="t" lIns="18288" rIns="18288">
-            <a:normAutofit/>
-          </a:bodyPr>
-          <a:lstStyle/>
-          <a:p>
-            <a:pPr algn="l"/>
-            <a:r>
-              <a:rPr sz="2100" b="1">
-                <a:solidFill>
-                  <a:srgbClr val="000000"/>
-                </a:solidFill>
-                <a:latin typeface="Aptos"/>
-              </a:rPr>
-              <a:t>CSV</a:t>
+            <a:off x="9619488" y="1453896"/>
+            <a:ext cx="1746504" cy="329184"/>
+          </a:xfrm>
+          <a:prstGeom prst="rect">
+            <a:avLst/>
+          </a:prstGeom>
+          <a:noFill/>
+        </p:spPr>
+        <p:txBody>
+          <a:bodyPr wrap="square" anchor="ctr" lIns="45720" rIns="45720" tIns="18288" bIns="18288">
+            <a:normAutofit/>
+          </a:bodyPr>
+          <a:lstStyle/>
+          <a:p>
+            <a:pPr algn="ctr"/>
+            <a:r>
+              <a:rPr sz="1800" b="1">
+                <a:solidFill>
+                  <a:srgbClr val="000000"/>
+                </a:solidFill>
+                <a:latin typeface="Aptos"/>
+              </a:rPr>
+              <a:t>Competencia</a:t>
             </a:r>
           </a:p>
         </p:txBody>
@@ -7914,29 +7878,29 @@
         </p:nvSpPr>
         <p:spPr>
           <a:xfrm>
-            <a:off x="9619488" y="1892807"/>
-            <a:ext cx="1746504" cy="228600"/>
-          </a:xfrm>
-          <a:prstGeom prst="rect">
-            <a:avLst/>
-          </a:prstGeom>
-          <a:noFill/>
-        </p:spPr>
-        <p:txBody>
-          <a:bodyPr wrap="square" anchor="t" lIns="18288" rIns="18288">
-            <a:normAutofit/>
-          </a:bodyPr>
-          <a:lstStyle/>
-          <a:p>
-            <a:pPr algn="l"/>
-            <a:r>
-              <a:rPr sz="919" b="0">
-                <a:solidFill>
-                  <a:srgbClr val="000000"/>
-                </a:solidFill>
-                <a:latin typeface="Aptos"/>
-              </a:rPr>
-              <a:t>final</a:t>
+            <a:off x="9619488" y="1847088"/>
+            <a:ext cx="1746504" cy="246888"/>
+          </a:xfrm>
+          <a:prstGeom prst="rect">
+            <a:avLst/>
+          </a:prstGeom>
+          <a:noFill/>
+        </p:spPr>
+        <p:txBody>
+          <a:bodyPr wrap="square" anchor="ctr" lIns="45720" rIns="45720" tIns="18288" bIns="18288">
+            <a:normAutofit/>
+          </a:bodyPr>
+          <a:lstStyle/>
+          <a:p>
+            <a:pPr algn="ctr"/>
+            <a:r>
+              <a:rPr sz="860" b="0">
+                <a:solidFill>
+                  <a:srgbClr val="5F5F5F"/>
+                </a:solidFill>
+                <a:latin typeface="Aptos"/>
+              </a:rPr>
+              <a:t>mejor score público</a:t>
             </a:r>
           </a:p>
         </p:txBody>
@@ -8332,23 +8296,23 @@
         </p:nvSpPr>
         <p:spPr>
           <a:xfrm>
-            <a:off x="685800" y="987552"/>
-            <a:ext cx="5120640" cy="320040"/>
-          </a:xfrm>
-          <a:prstGeom prst="rect">
-            <a:avLst/>
-          </a:prstGeom>
-          <a:noFill/>
-        </p:spPr>
-        <p:txBody>
-          <a:bodyPr wrap="square" anchor="t" lIns="18288" rIns="18288">
+            <a:off x="685800" y="1005840"/>
+            <a:ext cx="5257800" cy="320040"/>
+          </a:xfrm>
+          <a:prstGeom prst="rect">
+            <a:avLst/>
+          </a:prstGeom>
+          <a:noFill/>
+        </p:spPr>
+        <p:txBody>
+          <a:bodyPr wrap="square" anchor="ctr" lIns="45720" rIns="45720" tIns="18288" bIns="18288">
             <a:normAutofit/>
           </a:bodyPr>
           <a:lstStyle/>
           <a:p>
             <a:pPr algn="l"/>
             <a:r>
-              <a:rPr sz="2200" b="1">
+              <a:rPr sz="1700" b="1">
                 <a:solidFill>
                   <a:srgbClr val="000000"/>
                 </a:solidFill>
@@ -8367,21 +8331,21 @@
         </p:nvSpPr>
         <p:spPr>
           <a:xfrm>
-            <a:off x="731520" y="1444752"/>
-            <a:ext cx="5074920" cy="3246120"/>
-          </a:xfrm>
-          <a:prstGeom prst="rect">
-            <a:avLst/>
-          </a:prstGeom>
-          <a:noFill/>
-        </p:spPr>
-        <p:txBody>
-          <a:bodyPr wrap="square" lIns="73152" rIns="73152" tIns="18288">
-            <a:normAutofit/>
-          </a:bodyPr>
-          <a:lstStyle/>
-          <a:p>
-            <a:pPr>
+            <a:off x="749808" y="1481328"/>
+            <a:ext cx="5074920" cy="2331720"/>
+          </a:xfrm>
+          <a:prstGeom prst="rect">
+            <a:avLst/>
+          </a:prstGeom>
+          <a:noFill/>
+        </p:spPr>
+        <p:txBody>
+          <a:bodyPr wrap="square" lIns="45720" rIns="45720" tIns="18288" bIns="18288" anchor="ctr">
+            <a:normAutofit/>
+          </a:bodyPr>
+          <a:lstStyle/>
+          <a:p>
+            <a:pPr algn="l">
               <a:spcAft>
                 <a:spcPts val="400"/>
               </a:spcAft>
@@ -8393,11 +8357,77 @@
               </a:defRPr>
             </a:pPr>
             <a:r>
-              <a:t>Drift fuerte: test tiene géneros/subgéneros casi ausentes en train.</a:t>
-            </a:r>
-          </a:p>
-          <a:p>
-            <a:pPr>
+              <a:rPr sz="1420" b="0">
+                <a:solidFill>
+                  <a:srgbClr val="000000"/>
+                </a:solidFill>
+                <a:latin typeface="Aptos"/>
+              </a:rPr>
+              <a:t>Drift fuerte entre train y test: aparecen géneros y subgéneros casi ausentes en entrenamiento.
+El leaderboard público cubre solo una parte del test y puede favorecer ajustes demasiado específicos.
+La validación interna no replica del todo la lógica pública de Kaggle.</a:t>
+            </a:r>
+          </a:p>
+        </p:txBody>
+      </p:sp>
+      <p:sp>
+        <p:nvSpPr>
+          <p:cNvPr id="6" name="TextBox 5"/>
+          <p:cNvSpPr txBox="1"/>
+          <p:nvPr/>
+        </p:nvSpPr>
+        <p:spPr>
+          <a:xfrm>
+            <a:off x="6400800" y="1005840"/>
+            <a:ext cx="5257800" cy="320040"/>
+          </a:xfrm>
+          <a:prstGeom prst="rect">
+            <a:avLst/>
+          </a:prstGeom>
+          <a:noFill/>
+        </p:spPr>
+        <p:txBody>
+          <a:bodyPr wrap="square" anchor="ctr" lIns="45720" rIns="45720" tIns="18288" bIns="18288">
+            <a:normAutofit/>
+          </a:bodyPr>
+          <a:lstStyle/>
+          <a:p>
+            <a:pPr algn="l"/>
+            <a:r>
+              <a:rPr sz="1700" b="1">
+                <a:solidFill>
+                  <a:srgbClr val="000000"/>
+                </a:solidFill>
+                <a:latin typeface="Aptos"/>
+              </a:rPr>
+              <a:t>Posibles mejoras</a:t>
+            </a:r>
+          </a:p>
+        </p:txBody>
+      </p:sp>
+      <p:sp>
+        <p:nvSpPr>
+          <p:cNvPr id="7" name="TextBox 6"/>
+          <p:cNvSpPr txBox="1"/>
+          <p:nvPr/>
+        </p:nvSpPr>
+        <p:spPr>
+          <a:xfrm>
+            <a:off x="6464808" y="1481328"/>
+            <a:ext cx="5074920" cy="2331720"/>
+          </a:xfrm>
+          <a:prstGeom prst="rect">
+            <a:avLst/>
+          </a:prstGeom>
+          <a:noFill/>
+        </p:spPr>
+        <p:txBody>
+          <a:bodyPr wrap="square" lIns="45720" rIns="45720" tIns="18288" bIns="18288" anchor="ctr">
+            <a:normAutofit/>
+          </a:bodyPr>
+          <a:lstStyle/>
+          <a:p>
+            <a:pPr algn="l">
               <a:spcAft>
                 <a:spcPts val="400"/>
               </a:spcAft>
@@ -8409,181 +8439,304 @@
               </a:defRPr>
             </a:pPr>
             <a:r>
-              <a:t>El leaderboard público representa solo una parte del test.</a:t>
+              <a:rPr sz="1420" b="0">
+                <a:solidFill>
+                  <a:srgbClr val="000000"/>
+                </a:solidFill>
+                <a:latin typeface="Aptos"/>
+              </a:rPr>
+              <a:t>Diseñar una validación más parecida al test público usando cortes por artista, género y subgénero.
+Automatizar reglas de corrección para no depender de decisiones manuales puntuales.
+Explorar datos externos y modelos especializados para categorías nuevas o con poco historial.</a:t>
+            </a:r>
+          </a:p>
+        </p:txBody>
+      </p:sp>
+      <p:sp>
+        <p:nvSpPr>
+          <p:cNvPr id="8" name="Rounded Rectangle 7"/>
+          <p:cNvSpPr/>
+          <p:nvPr/>
+        </p:nvSpPr>
+        <p:spPr>
+          <a:xfrm>
+            <a:off x="777240" y="4315968"/>
+            <a:ext cx="3429000" cy="1234440"/>
+          </a:xfrm>
+          <a:prstGeom prst="roundRect">
+            <a:avLst>
+              <a:gd name="adj" fmla="val 8000"/>
+            </a:avLst>
+          </a:prstGeom>
+          <a:solidFill>
+            <a:srgbClr val="F8F8F8"/>
+          </a:solidFill>
+          <a:ln>
+            <a:noFill/>
+          </a:ln>
+        </p:spPr>
+        <p:style>
+          <a:lnRef idx="1">
+            <a:schemeClr val="accent1"/>
+          </a:lnRef>
+          <a:fillRef idx="3">
+            <a:schemeClr val="accent1"/>
+          </a:fillRef>
+          <a:effectRef idx="2">
+            <a:schemeClr val="accent1"/>
+          </a:effectRef>
+          <a:fontRef idx="minor">
+            <a:schemeClr val="lt1"/>
+          </a:fontRef>
+        </p:style>
+        <p:txBody>
+          <a:bodyPr rtlCol="0" anchor="ctr"/>
+          <a:lstStyle/>
+          <a:p>
+            <a:pPr algn="ctr"/>
+          </a:p>
+        </p:txBody>
+      </p:sp>
+      <p:sp>
+        <p:nvSpPr>
+          <p:cNvPr id="9" name="TextBox 8"/>
+          <p:cNvSpPr txBox="1"/>
+          <p:nvPr/>
+        </p:nvSpPr>
+        <p:spPr>
+          <a:xfrm>
+            <a:off x="941832" y="4480559"/>
+            <a:ext cx="3099816" cy="941832"/>
+          </a:xfrm>
+          <a:prstGeom prst="rect">
+            <a:avLst/>
+          </a:prstGeom>
+          <a:noFill/>
+        </p:spPr>
+        <p:txBody>
+          <a:bodyPr wrap="square" lIns="0" rIns="0" tIns="0" bIns="0">
+            <a:spAutoFit/>
+          </a:bodyPr>
+          <a:lstStyle/>
+          <a:p>
+            <a:r>
+              <a:rPr sz="1300" b="1">
+                <a:solidFill>
+                  <a:srgbClr val="000000"/>
+                </a:solidFill>
+                <a:latin typeface="Aptos"/>
+              </a:rPr>
+              <a:t>Limitación crítica</a:t>
             </a:r>
           </a:p>
           <a:p>
             <a:pPr>
-              <a:spcAft>
-                <a:spcPts val="400"/>
-              </a:spcAft>
-              <a:defRPr sz="1530">
-                <a:solidFill>
-                  <a:srgbClr val="000000"/>
-                </a:solidFill>
-                <a:latin typeface="Aptos"/>
-              </a:defRPr>
+              <a:spcBef>
+                <a:spcPts val="700"/>
+              </a:spcBef>
             </a:pPr>
             <a:r>
-              <a:t>Los ajustes por subgénero dependen de hipótesis manuales.</a:t>
+              <a:rPr sz="1100">
+                <a:solidFill>
+                  <a:srgbClr val="232323"/>
+                </a:solidFill>
+                <a:latin typeface="Aptos"/>
+              </a:rPr>
+              <a:t>El cambio de distribución fue el cuello de botella principal.</a:t>
+            </a:r>
+          </a:p>
+        </p:txBody>
+      </p:sp>
+      <p:sp>
+        <p:nvSpPr>
+          <p:cNvPr id="10" name="Rounded Rectangle 9"/>
+          <p:cNvSpPr/>
+          <p:nvPr/>
+        </p:nvSpPr>
+        <p:spPr>
+          <a:xfrm>
+            <a:off x="4526279" y="4315968"/>
+            <a:ext cx="3429000" cy="1234440"/>
+          </a:xfrm>
+          <a:prstGeom prst="roundRect">
+            <a:avLst>
+              <a:gd name="adj" fmla="val 8000"/>
+            </a:avLst>
+          </a:prstGeom>
+          <a:solidFill>
+            <a:srgbClr val="F8F8F8"/>
+          </a:solidFill>
+          <a:ln>
+            <a:noFill/>
+          </a:ln>
+        </p:spPr>
+        <p:style>
+          <a:lnRef idx="1">
+            <a:schemeClr val="accent1"/>
+          </a:lnRef>
+          <a:fillRef idx="3">
+            <a:schemeClr val="accent1"/>
+          </a:fillRef>
+          <a:effectRef idx="2">
+            <a:schemeClr val="accent1"/>
+          </a:effectRef>
+          <a:fontRef idx="minor">
+            <a:schemeClr val="lt1"/>
+          </a:fontRef>
+        </p:style>
+        <p:txBody>
+          <a:bodyPr rtlCol="0" anchor="ctr"/>
+          <a:lstStyle/>
+          <a:p>
+            <a:pPr algn="ctr"/>
+          </a:p>
+        </p:txBody>
+      </p:sp>
+      <p:sp>
+        <p:nvSpPr>
+          <p:cNvPr id="11" name="TextBox 10"/>
+          <p:cNvSpPr txBox="1"/>
+          <p:nvPr/>
+        </p:nvSpPr>
+        <p:spPr>
+          <a:xfrm>
+            <a:off x="4690871" y="4480559"/>
+            <a:ext cx="3099816" cy="941832"/>
+          </a:xfrm>
+          <a:prstGeom prst="rect">
+            <a:avLst/>
+          </a:prstGeom>
+          <a:noFill/>
+        </p:spPr>
+        <p:txBody>
+          <a:bodyPr wrap="square" lIns="0" rIns="0" tIns="0" bIns="0">
+            <a:spAutoFit/>
+          </a:bodyPr>
+          <a:lstStyle/>
+          <a:p>
+            <a:r>
+              <a:rPr sz="1300" b="1">
+                <a:solidFill>
+                  <a:srgbClr val="000000"/>
+                </a:solidFill>
+                <a:latin typeface="Aptos"/>
+              </a:rPr>
+              <a:t>Riesgo del mejor score</a:t>
             </a:r>
           </a:p>
           <a:p>
             <a:pPr>
-              <a:spcAft>
-                <a:spcPts val="400"/>
-              </a:spcAft>
-              <a:defRPr sz="1530">
-                <a:solidFill>
-                  <a:srgbClr val="000000"/>
-                </a:solidFill>
-                <a:latin typeface="Aptos"/>
-              </a:defRPr>
+              <a:spcBef>
+                <a:spcPts val="700"/>
+              </a:spcBef>
             </a:pPr>
             <a:r>
-              <a:t>La validación interna no replica completamente Kaggle.</a:t>
+              <a:rPr sz="1100">
+                <a:solidFill>
+                  <a:srgbClr val="232323"/>
+                </a:solidFill>
+                <a:latin typeface="Aptos"/>
+              </a:rPr>
+              <a:t>Puede estar optimizado al subconjunto público del leaderboard.</a:t>
+            </a:r>
+          </a:p>
+        </p:txBody>
+      </p:sp>
+      <p:sp>
+        <p:nvSpPr>
+          <p:cNvPr id="12" name="Rounded Rectangle 11"/>
+          <p:cNvSpPr/>
+          <p:nvPr/>
+        </p:nvSpPr>
+        <p:spPr>
+          <a:xfrm>
+            <a:off x="8275319" y="4315968"/>
+            <a:ext cx="3429000" cy="1234440"/>
+          </a:xfrm>
+          <a:prstGeom prst="roundRect">
+            <a:avLst>
+              <a:gd name="adj" fmla="val 8000"/>
+            </a:avLst>
+          </a:prstGeom>
+          <a:solidFill>
+            <a:srgbClr val="F8F8F8"/>
+          </a:solidFill>
+          <a:ln>
+            <a:noFill/>
+          </a:ln>
+        </p:spPr>
+        <p:style>
+          <a:lnRef idx="1">
+            <a:schemeClr val="accent1"/>
+          </a:lnRef>
+          <a:fillRef idx="3">
+            <a:schemeClr val="accent1"/>
+          </a:fillRef>
+          <a:effectRef idx="2">
+            <a:schemeClr val="accent1"/>
+          </a:effectRef>
+          <a:fontRef idx="minor">
+            <a:schemeClr val="lt1"/>
+          </a:fontRef>
+        </p:style>
+        <p:txBody>
+          <a:bodyPr rtlCol="0" anchor="ctr"/>
+          <a:lstStyle/>
+          <a:p>
+            <a:pPr algn="ctr"/>
+          </a:p>
+        </p:txBody>
+      </p:sp>
+      <p:sp>
+        <p:nvSpPr>
+          <p:cNvPr id="13" name="TextBox 12"/>
+          <p:cNvSpPr txBox="1"/>
+          <p:nvPr/>
+        </p:nvSpPr>
+        <p:spPr>
+          <a:xfrm>
+            <a:off x="8439911" y="4480559"/>
+            <a:ext cx="3099816" cy="941832"/>
+          </a:xfrm>
+          <a:prstGeom prst="rect">
+            <a:avLst/>
+          </a:prstGeom>
+          <a:noFill/>
+        </p:spPr>
+        <p:txBody>
+          <a:bodyPr wrap="square" lIns="0" rIns="0" tIns="0" bIns="0">
+            <a:spAutoFit/>
+          </a:bodyPr>
+          <a:lstStyle/>
+          <a:p>
+            <a:r>
+              <a:rPr sz="1300" b="1">
+                <a:solidFill>
+                  <a:srgbClr val="000000"/>
+                </a:solidFill>
+                <a:latin typeface="Aptos"/>
+              </a:rPr>
+              <a:t>Mejora prioritaria</a:t>
             </a:r>
           </a:p>
           <a:p>
             <a:pPr>
-              <a:spcAft>
-                <a:spcPts val="400"/>
-              </a:spcAft>
-              <a:defRPr sz="1530">
-                <a:solidFill>
-                  <a:srgbClr val="000000"/>
-                </a:solidFill>
-                <a:latin typeface="Aptos"/>
-              </a:defRPr>
+              <a:spcBef>
+                <a:spcPts val="700"/>
+              </a:spcBef>
             </a:pPr>
             <a:r>
-              <a:t>El modelo de competencia puede sobreajustar al público.</a:t>
-            </a:r>
-          </a:p>
-        </p:txBody>
-      </p:sp>
-      <p:sp>
-        <p:nvSpPr>
-          <p:cNvPr id="6" name="TextBox 5"/>
-          <p:cNvSpPr txBox="1"/>
-          <p:nvPr/>
-        </p:nvSpPr>
-        <p:spPr>
-          <a:xfrm>
-            <a:off x="685800" y="4892040"/>
-            <a:ext cx="5120640" cy="320040"/>
-          </a:xfrm>
-          <a:prstGeom prst="rect">
-            <a:avLst/>
-          </a:prstGeom>
-          <a:noFill/>
-        </p:spPr>
-        <p:txBody>
-          <a:bodyPr wrap="square" anchor="t" lIns="18288" rIns="18288">
-            <a:normAutofit/>
-          </a:bodyPr>
-          <a:lstStyle/>
-          <a:p>
-            <a:pPr algn="l"/>
-            <a:r>
-              <a:rPr sz="2200" b="1">
-                <a:solidFill>
-                  <a:srgbClr val="000000"/>
-                </a:solidFill>
-                <a:latin typeface="Aptos"/>
-              </a:rPr>
-              <a:t>Mejoras con más tiempo</a:t>
-            </a:r>
-          </a:p>
-        </p:txBody>
-      </p:sp>
-      <p:sp>
-        <p:nvSpPr>
-          <p:cNvPr id="7" name="TextBox 6"/>
-          <p:cNvSpPr txBox="1"/>
-          <p:nvPr/>
-        </p:nvSpPr>
-        <p:spPr>
-          <a:xfrm>
-            <a:off x="731520" y="5321808"/>
-            <a:ext cx="5074920" cy="822960"/>
-          </a:xfrm>
-          <a:prstGeom prst="rect">
-            <a:avLst/>
-          </a:prstGeom>
-          <a:noFill/>
-        </p:spPr>
-        <p:txBody>
-          <a:bodyPr wrap="square" lIns="73152" rIns="73152" tIns="18288">
-            <a:normAutofit/>
-          </a:bodyPr>
-          <a:lstStyle/>
-          <a:p>
-            <a:pPr>
-              <a:spcAft>
-                <a:spcPts val="400"/>
-              </a:spcAft>
-              <a:defRPr sz="1530">
-                <a:solidFill>
-                  <a:srgbClr val="000000"/>
-                </a:solidFill>
-                <a:latin typeface="Aptos"/>
-              </a:defRPr>
-            </a:pPr>
-            <a:r>
-              <a:t>Mejor validación de drift, datos externos, modelos por subgénero y reglas automatizadas.</a:t>
-            </a:r>
-          </a:p>
-        </p:txBody>
-      </p:sp>
-      <p:pic>
-        <p:nvPicPr>
-          <p:cNvPr id="8" name="Picture 7" descr="que_funciono_y_que_no_canva.png"/>
-          <p:cNvPicPr>
-            <a:picLocks noChangeAspect="1"/>
-          </p:cNvPicPr>
-          <p:nvPr/>
-        </p:nvPicPr>
-        <p:blipFill>
-          <a:blip r:embed="rId2"/>
-          <a:stretch>
-            <a:fillRect/>
-          </a:stretch>
-        </p:blipFill>
-        <p:spPr>
-          <a:xfrm>
-            <a:off x="6309360" y="1063659"/>
-            <a:ext cx="5074920" cy="2856160"/>
-          </a:xfrm>
-          <a:prstGeom prst="rect">
-            <a:avLst/>
-          </a:prstGeom>
-        </p:spPr>
-      </p:pic>
-      <p:pic>
-        <p:nvPicPr>
-          <p:cNvPr id="9" name="Picture 8" descr="eda_correlaciones_audio_canva.png"/>
-          <p:cNvPicPr>
-            <a:picLocks noChangeAspect="1"/>
-          </p:cNvPicPr>
-          <p:nvPr/>
-        </p:nvPicPr>
-        <p:blipFill>
-          <a:blip r:embed="rId3"/>
-          <a:stretch>
-            <a:fillRect/>
-          </a:stretch>
-        </p:blipFill>
-        <p:spPr>
-          <a:xfrm>
-            <a:off x="7302500" y="4315968"/>
-            <a:ext cx="3088639" cy="1737360"/>
-          </a:xfrm>
-          <a:prstGeom prst="rect">
-            <a:avLst/>
-          </a:prstGeom>
-        </p:spPr>
-      </p:pic>
+              <a:rPr sz="1100">
+                <a:solidFill>
+                  <a:srgbClr val="232323"/>
+                </a:solidFill>
+                <a:latin typeface="Aptos"/>
+              </a:rPr>
+              <a:t>Validación de drift antes de seguir sumando modelos.</a:t>
+            </a:r>
+          </a:p>
+        </p:txBody>
+      </p:sp>
     </p:spTree>
   </p:cSld>
   <p:clrMapOvr>

</xml_diff>